<commit_message>
feat(pitch): enhance deck vibrancy, projector-scale fonts, high contrast badges, and presenter notes
</commit_message>
<xml_diff>
--- a/VERITAS_Pitch_Deck.pptx
+++ b/VERITAS_Pitch_Deck.pptx
@@ -4,24 +4,27 @@
   <p:sldMasterIdLst>
     <p:sldMasterId id="2147483648" r:id="rId1"/>
   </p:sldMasterIdLst>
+  <p:notesMasterIdLst>
+    <p:notesMasterId r:id="rId17"/>
+  </p:notesMasterIdLst>
   <p:sldIdLst>
-    <p:sldId id="256" r:id="rId7"/>
-    <p:sldId id="257" r:id="rId9"/>
-    <p:sldId id="258" r:id="rId10"/>
-    <p:sldId id="259" r:id="rId11"/>
-    <p:sldId id="260" r:id="rId12"/>
-    <p:sldId id="261" r:id="rId13"/>
-    <p:sldId id="262" r:id="rId14"/>
-    <p:sldId id="263" r:id="rId15"/>
-    <p:sldId id="264" r:id="rId16"/>
-    <p:sldId id="265" r:id="rId17"/>
-    <p:sldId id="266" r:id="rId18"/>
-    <p:sldId id="267" r:id="rId19"/>
-    <p:sldId id="268" r:id="rId20"/>
-    <p:sldId id="269" r:id="rId21"/>
-    <p:sldId id="270" r:id="rId22"/>
+    <p:sldId id="256" r:id="rId2"/>
+    <p:sldId id="257" r:id="rId3"/>
+    <p:sldId id="258" r:id="rId4"/>
+    <p:sldId id="259" r:id="rId5"/>
+    <p:sldId id="260" r:id="rId6"/>
+    <p:sldId id="261" r:id="rId7"/>
+    <p:sldId id="262" r:id="rId8"/>
+    <p:sldId id="263" r:id="rId9"/>
+    <p:sldId id="264" r:id="rId10"/>
+    <p:sldId id="265" r:id="rId11"/>
+    <p:sldId id="266" r:id="rId12"/>
+    <p:sldId id="267" r:id="rId13"/>
+    <p:sldId id="268" r:id="rId14"/>
+    <p:sldId id="269" r:id="rId15"/>
+    <p:sldId id="270" r:id="rId16"/>
   </p:sldIdLst>
-  <p:sldSz cx="12191695" cy="6858000" type="screen4x3"/>
+  <p:sldSz cx="12192000" cy="6858000"/>
   <p:notesSz cx="6858000" cy="9144000"/>
   <p:defaultTextStyle>
     <a:defPPr>
@@ -118,11 +121,56 @@
       </a:defRPr>
     </a:lvl9pPr>
   </p:defaultTextStyle>
+  <p:extLst>
+    <p:ext uri="{EFAFB233-063F-42B5-8137-9DF3F51BA10A}">
+      <p15:sldGuideLst xmlns:p15="http://schemas.microsoft.com/office/powerpoint/2012/main">
+        <p15:guide id="1" orient="horz" pos="2160">
+          <p15:clr>
+            <a:srgbClr val="A4A3A4"/>
+          </p15:clr>
+        </p15:guide>
+        <p15:guide id="2" pos="2880">
+          <p15:clr>
+            <a:srgbClr val="A4A3A4"/>
+          </p15:clr>
+        </p15:guide>
+      </p15:sldGuideLst>
+    </p:ext>
+  </p:extLst>
 </p:presentation>
 </file>
 
+<file path=ppt/changesInfos/changesInfo1.xml><?xml version="1.0" encoding="utf-8"?>
+<pc:chgInfo xmlns:a="http://schemas.openxmlformats.org/drawingml/2006/main" xmlns:r="http://schemas.openxmlformats.org/officeDocument/2006/relationships" xmlns:ac="http://schemas.microsoft.com/office/drawing/2013/main/command" xmlns:pc="http://schemas.microsoft.com/office/powerpoint/2013/main/command">
+  <pc:docChgLst>
+    <pc:chgData name="DEBARGHA CHAKRABORTY" userId="49dc778136e0bcf5" providerId="LiveId" clId="{BDF8B5AA-CAD8-4B24-8C73-C6E4E7336269}"/>
+    <pc:docChg chg="custSel modSld">
+      <pc:chgData name="DEBARGHA CHAKRABORTY" userId="49dc778136e0bcf5" providerId="LiveId" clId="{BDF8B5AA-CAD8-4B24-8C73-C6E4E7336269}" dt="2026-10-22T14:54:27.495" v="65" actId="14100"/>
+      <pc:docMkLst>
+        <pc:docMk/>
+      </pc:docMkLst>
+      <pc:sldChg chg="modSp mod">
+        <pc:chgData name="DEBARGHA CHAKRABORTY" userId="49dc778136e0bcf5" providerId="LiveId" clId="{BDF8B5AA-CAD8-4B24-8C73-C6E4E7336269}" dt="2026-10-22T14:54:27.495" v="65" actId="14100"/>
+        <pc:sldMkLst>
+          <pc:docMk/>
+          <pc:sldMk cId="0" sldId="256"/>
+        </pc:sldMkLst>
+        <pc:spChg chg="mod">
+          <ac:chgData name="DEBARGHA CHAKRABORTY" userId="49dc778136e0bcf5" providerId="LiveId" clId="{BDF8B5AA-CAD8-4B24-8C73-C6E4E7336269}" dt="2026-10-22T14:54:27.495" v="65" actId="14100"/>
+          <ac:spMkLst>
+            <pc:docMk/>
+            <pc:sldMk cId="0" sldId="256"/>
+            <ac:spMk id="4" creationId="{00000000-0000-0000-0000-000000000000}"/>
+          </ac:spMkLst>
+        </pc:spChg>
+      </pc:sldChg>
+    </pc:docChg>
+  </pc:docChgLst>
+</pc:chgInfo>
+</file>
+
 <file path=ppt/notesMasters/notesMaster1.xml><?xml version="1.0" encoding="utf-8"?>
-<p:notesMaster xmlns:a="http://schemas.openxmlformats.org/drawingml/2006/main" xmlns:p="http://schemas.openxmlformats.org/presentationml/2006/main" xmlns:r="http://schemas.openxmlformats.org/officeDocument/2006/relationships">
+<p:notesMaster xmlns:a="http://schemas.openxmlformats.org/drawingml/2006/main" xmlns:r="http://schemas.openxmlformats.org/officeDocument/2006/relationships" xmlns:p="http://schemas.openxmlformats.org/presentationml/2006/main">
   <p:cSld>
     <p:bg>
       <p:bgRef idx="1001">
@@ -143,241 +191,16 @@
           <a:chExt cx="0" cy="0"/>
         </a:xfrm>
       </p:grpSpPr>
-      <p:sp>
-        <p:nvSpPr>
-          <p:cNvPr id="2" name="Header Placeholder 1"/>
-          <p:cNvSpPr>
-            <a:spLocks noGrp="1"/>
-          </p:cNvSpPr>
-          <p:nvPr>
-            <p:ph type="hdr" sz="quarter"/>
-          </p:nvPr>
-        </p:nvSpPr>
-        <p:spPr>
-          <a:xfrm>
-            <a:off x="0" y="0"/>
-            <a:ext cx="2971800" cy="457200"/>
-          </a:xfrm>
-          <a:prstGeom prst="rect">
-            <a:avLst/>
-          </a:prstGeom>
-        </p:spPr>
-        <p:txBody>
-          <a:bodyPr vert="horz" lIns="91440" tIns="45720" rIns="91440" bIns="45720" rtlCol="0"/>
-          <a:lstStyle>
-            <a:lvl1pPr algn="l">
-              <a:defRPr sz="1200"/>
-            </a:lvl1pPr>
-          </a:lstStyle>
-          <a:p>
-            <a:endParaRPr lang="en-US"/>
-          </a:p>
-        </p:txBody>
-      </p:sp>
-      <p:sp>
-        <p:nvSpPr>
-          <p:cNvPr id="3" name="Date Placeholder 2"/>
-          <p:cNvSpPr>
-            <a:spLocks noGrp="1"/>
-          </p:cNvSpPr>
-          <p:nvPr>
-            <p:ph type="dt" idx="1"/>
-          </p:nvPr>
-        </p:nvSpPr>
-        <p:spPr>
-          <a:xfrm>
-            <a:off x="3884613" y="0"/>
-            <a:ext cx="2971800" cy="457200"/>
-          </a:xfrm>
-          <a:prstGeom prst="rect">
-            <a:avLst/>
-          </a:prstGeom>
-        </p:spPr>
-        <p:txBody>
-          <a:bodyPr vert="horz" lIns="91440" tIns="45720" rIns="91440" bIns="45720" rtlCol="0"/>
-          <a:lstStyle>
-            <a:lvl1pPr algn="r">
-              <a:defRPr sz="1200"/>
-            </a:lvl1pPr>
-          </a:lstStyle>
-          <a:p>
-            <a:fld id="{0F89C1C7-3DCD-1040-A9CF-14679D8B5DDD}" type="datetimeFigureOut">
-              <a:rPr lang="en-US" smtClean="0"/>
-              <a:t>10/17/16</a:t>
-            </a:fld>
-            <a:endParaRPr lang="en-US"/>
-          </a:p>
-        </p:txBody>
-      </p:sp>
-      <p:sp>
-        <p:nvSpPr>
-          <p:cNvPr id="4" name="Slide Image Placeholder 3"/>
-          <p:cNvSpPr>
-            <a:spLocks noGrp="1" noRot="1" noChangeAspect="1"/>
-          </p:cNvSpPr>
-          <p:nvPr>
-            <p:ph type="sldImg" idx="2"/>
-          </p:nvPr>
-        </p:nvSpPr>
-        <p:spPr>
-          <a:xfrm>
-            <a:off x="1143000" y="685800"/>
-            <a:ext cx="4572000" cy="3429000"/>
-          </a:xfrm>
-          <a:prstGeom prst="rect">
-            <a:avLst/>
-          </a:prstGeom>
-          <a:noFill/>
-          <a:ln w="12700">
-            <a:solidFill>
-              <a:prstClr val="black"/>
-            </a:solidFill>
-          </a:ln>
-        </p:spPr>
-        <p:txBody>
-          <a:bodyPr vert="horz" lIns="91440" tIns="45720" rIns="91440" bIns="45720" rtlCol="0" anchor="ctr"/>
-          <a:lstStyle/>
-          <a:p>
-            <a:endParaRPr lang="en-US"/>
-          </a:p>
-        </p:txBody>
-      </p:sp>
-      <p:sp>
-        <p:nvSpPr>
-          <p:cNvPr id="5" name="Notes Placeholder 4"/>
-          <p:cNvSpPr>
-            <a:spLocks noGrp="1"/>
-          </p:cNvSpPr>
-          <p:nvPr>
-            <p:ph type="body" sz="quarter" idx="3"/>
-          </p:nvPr>
-        </p:nvSpPr>
-        <p:spPr>
-          <a:xfrm>
-            <a:off x="685800" y="4343400"/>
-            <a:ext cx="5486400" cy="4114800"/>
-          </a:xfrm>
-          <a:prstGeom prst="rect">
-            <a:avLst/>
-          </a:prstGeom>
-        </p:spPr>
-        <p:txBody>
-          <a:bodyPr vert="horz" lIns="91440" tIns="45720" rIns="91440" bIns="45720" rtlCol="0"/>
-          <a:lstStyle/>
-          <a:p>
-            <a:pPr lvl="0"/>
-            <a:r>
-              <a:rPr lang="en-US" smtClean="0"/>
-              <a:t>Click to edit Master text styles</a:t>
-            </a:r>
-          </a:p>
-          <a:p>
-            <a:pPr lvl="1"/>
-            <a:r>
-              <a:rPr lang="en-US" smtClean="0"/>
-              <a:t>Second level</a:t>
-            </a:r>
-          </a:p>
-          <a:p>
-            <a:pPr lvl="2"/>
-            <a:r>
-              <a:rPr lang="en-US" smtClean="0"/>
-              <a:t>Third level</a:t>
-            </a:r>
-          </a:p>
-          <a:p>
-            <a:pPr lvl="3"/>
-            <a:r>
-              <a:rPr lang="en-US" smtClean="0"/>
-              <a:t>Fourth level</a:t>
-            </a:r>
-          </a:p>
-          <a:p>
-            <a:pPr lvl="4"/>
-            <a:r>
-              <a:rPr lang="en-US" smtClean="0"/>
-              <a:t>Fifth level</a:t>
-            </a:r>
-            <a:endParaRPr lang="en-US"/>
-          </a:p>
-        </p:txBody>
-      </p:sp>
-      <p:sp>
-        <p:nvSpPr>
-          <p:cNvPr id="6" name="Footer Placeholder 5"/>
-          <p:cNvSpPr>
-            <a:spLocks noGrp="1"/>
-          </p:cNvSpPr>
-          <p:nvPr>
-            <p:ph type="ftr" sz="quarter" idx="4"/>
-          </p:nvPr>
-        </p:nvSpPr>
-        <p:spPr>
-          <a:xfrm>
-            <a:off x="0" y="8685213"/>
-            <a:ext cx="2971800" cy="457200"/>
-          </a:xfrm>
-          <a:prstGeom prst="rect">
-            <a:avLst/>
-          </a:prstGeom>
-        </p:spPr>
-        <p:txBody>
-          <a:bodyPr vert="horz" lIns="91440" tIns="45720" rIns="91440" bIns="45720" rtlCol="0" anchor="b"/>
-          <a:lstStyle>
-            <a:lvl1pPr algn="l">
-              <a:defRPr sz="1200"/>
-            </a:lvl1pPr>
-          </a:lstStyle>
-          <a:p>
-            <a:endParaRPr lang="en-US"/>
-          </a:p>
-        </p:txBody>
-      </p:sp>
-      <p:sp>
-        <p:nvSpPr>
-          <p:cNvPr id="7" name="Slide Number Placeholder 6"/>
-          <p:cNvSpPr>
-            <a:spLocks noGrp="1"/>
-          </p:cNvSpPr>
-          <p:nvPr>
-            <p:ph type="sldNum" sz="quarter" idx="5"/>
-          </p:nvPr>
-        </p:nvSpPr>
-        <p:spPr>
-          <a:xfrm>
-            <a:off x="3884613" y="8685213"/>
-            <a:ext cx="2971800" cy="457200"/>
-          </a:xfrm>
-          <a:prstGeom prst="rect">
-            <a:avLst/>
-          </a:prstGeom>
-        </p:spPr>
-        <p:txBody>
-          <a:bodyPr vert="horz" lIns="91440" tIns="45720" rIns="91440" bIns="45720" rtlCol="0" anchor="b"/>
-          <a:lstStyle>
-            <a:lvl1pPr algn="r">
-              <a:defRPr sz="1200"/>
-            </a:lvl1pPr>
-          </a:lstStyle>
-          <a:p>
-            <a:fld id="{BB5E49A5-4136-284D-997B-48E1D791AD67}" type="slidenum">
-              <a:rPr lang="en-US" smtClean="0"/>
-              <a:t>‹#›</a:t>
-            </a:fld>
-            <a:endParaRPr lang="en-US"/>
-          </a:p>
-        </p:txBody>
-      </p:sp>
     </p:spTree>
     <p:extLst>
       <p:ext uri="{BB962C8B-B14F-4D97-AF65-F5344CB8AC3E}">
-        <p14:creationId xmlns:p14="http://schemas.microsoft.com/office/powerpoint/2010/main" val="2623252185"/>
+        <p14:creationId xmlns:p14="http://schemas.microsoft.com/office/powerpoint/2010/main" val="4169373314"/>
       </p:ext>
     </p:extLst>
   </p:cSld>
   <p:clrMap bg1="lt1" tx1="dk1" bg2="lt2" tx2="dk2" accent1="accent1" accent2="accent2" accent3="accent3" accent4="accent4" accent5="accent5" accent6="accent6" hlink="hlink" folHlink="folHlink"/>
   <p:notesStyle>
-    <a:lvl1pPr marL="0" algn="l" defTabSz="457200" rtl="0" eaLnBrk="1" latinLnBrk="0" hangingPunct="1">
+    <a:lvl1pPr marL="0" algn="l" defTabSz="914400" rtl="0" eaLnBrk="1" latinLnBrk="0" hangingPunct="1">
       <a:defRPr sz="1200" kern="1200">
         <a:solidFill>
           <a:schemeClr val="tx1"/>
@@ -387,7 +210,7 @@
         <a:cs typeface="+mn-cs"/>
       </a:defRPr>
     </a:lvl1pPr>
-    <a:lvl2pPr marL="457200" algn="l" defTabSz="457200" rtl="0" eaLnBrk="1" latinLnBrk="0" hangingPunct="1">
+    <a:lvl2pPr marL="457200" algn="l" defTabSz="914400" rtl="0" eaLnBrk="1" latinLnBrk="0" hangingPunct="1">
       <a:defRPr sz="1200" kern="1200">
         <a:solidFill>
           <a:schemeClr val="tx1"/>
@@ -397,7 +220,7 @@
         <a:cs typeface="+mn-cs"/>
       </a:defRPr>
     </a:lvl2pPr>
-    <a:lvl3pPr marL="914400" algn="l" defTabSz="457200" rtl="0" eaLnBrk="1" latinLnBrk="0" hangingPunct="1">
+    <a:lvl3pPr marL="914400" algn="l" defTabSz="914400" rtl="0" eaLnBrk="1" latinLnBrk="0" hangingPunct="1">
       <a:defRPr sz="1200" kern="1200">
         <a:solidFill>
           <a:schemeClr val="tx1"/>
@@ -407,7 +230,7 @@
         <a:cs typeface="+mn-cs"/>
       </a:defRPr>
     </a:lvl3pPr>
-    <a:lvl4pPr marL="1371600" algn="l" defTabSz="457200" rtl="0" eaLnBrk="1" latinLnBrk="0" hangingPunct="1">
+    <a:lvl4pPr marL="1371600" algn="l" defTabSz="914400" rtl="0" eaLnBrk="1" latinLnBrk="0" hangingPunct="1">
       <a:defRPr sz="1200" kern="1200">
         <a:solidFill>
           <a:schemeClr val="tx1"/>
@@ -417,7 +240,7 @@
         <a:cs typeface="+mn-cs"/>
       </a:defRPr>
     </a:lvl4pPr>
-    <a:lvl5pPr marL="1828800" algn="l" defTabSz="457200" rtl="0" eaLnBrk="1" latinLnBrk="0" hangingPunct="1">
+    <a:lvl5pPr marL="1828800" algn="l" defTabSz="914400" rtl="0" eaLnBrk="1" latinLnBrk="0" hangingPunct="1">
       <a:defRPr sz="1200" kern="1200">
         <a:solidFill>
           <a:schemeClr val="tx1"/>
@@ -427,7 +250,7 @@
         <a:cs typeface="+mn-cs"/>
       </a:defRPr>
     </a:lvl5pPr>
-    <a:lvl6pPr marL="2286000" algn="l" defTabSz="457200" rtl="0" eaLnBrk="1" latinLnBrk="0" hangingPunct="1">
+    <a:lvl6pPr marL="2286000" algn="l" defTabSz="914400" rtl="0" eaLnBrk="1" latinLnBrk="0" hangingPunct="1">
       <a:defRPr sz="1200" kern="1200">
         <a:solidFill>
           <a:schemeClr val="tx1"/>
@@ -437,7 +260,7 @@
         <a:cs typeface="+mn-cs"/>
       </a:defRPr>
     </a:lvl6pPr>
-    <a:lvl7pPr marL="2743200" algn="l" defTabSz="457200" rtl="0" eaLnBrk="1" latinLnBrk="0" hangingPunct="1">
+    <a:lvl7pPr marL="2743200" algn="l" defTabSz="914400" rtl="0" eaLnBrk="1" latinLnBrk="0" hangingPunct="1">
       <a:defRPr sz="1200" kern="1200">
         <a:solidFill>
           <a:schemeClr val="tx1"/>
@@ -447,7 +270,7 @@
         <a:cs typeface="+mn-cs"/>
       </a:defRPr>
     </a:lvl7pPr>
-    <a:lvl8pPr marL="3200400" algn="l" defTabSz="457200" rtl="0" eaLnBrk="1" latinLnBrk="0" hangingPunct="1">
+    <a:lvl8pPr marL="3200400" algn="l" defTabSz="914400" rtl="0" eaLnBrk="1" latinLnBrk="0" hangingPunct="1">
       <a:defRPr sz="1200" kern="1200">
         <a:solidFill>
           <a:schemeClr val="tx1"/>
@@ -457,7 +280,7 @@
         <a:cs typeface="+mn-cs"/>
       </a:defRPr>
     </a:lvl8pPr>
-    <a:lvl9pPr marL="3657600" algn="l" defTabSz="457200" rtl="0" eaLnBrk="1" latinLnBrk="0" hangingPunct="1">
+    <a:lvl9pPr marL="3657600" algn="l" defTabSz="914400" rtl="0" eaLnBrk="1" latinLnBrk="0" hangingPunct="1">
       <a:defRPr sz="1200" kern="1200">
         <a:solidFill>
           <a:schemeClr val="tx1"/>
@@ -472,7 +295,7 @@
 </file>
 
 <file path=ppt/notesSlides/notesSlide1.xml><?xml version="1.0" encoding="utf-8"?>
-<p:notes xmlns:a="http://schemas.openxmlformats.org/drawingml/2006/main" xmlns:p="http://schemas.openxmlformats.org/presentationml/2006/main" xmlns:r="http://schemas.openxmlformats.org/officeDocument/2006/relationships">
+<p:notes xmlns:a="http://schemas.openxmlformats.org/drawingml/2006/main" xmlns:r="http://schemas.openxmlformats.org/officeDocument/2006/relationships" xmlns:p="http://schemas.openxmlformats.org/presentationml/2006/main">
   <p:cSld>
     <p:spTree>
       <p:nvGrpSpPr>
@@ -492,7 +315,7 @@
         <p:nvSpPr>
           <p:cNvPr id="2" name="Slide Image Placeholder 1"/>
           <p:cNvSpPr>
-            <a:spLocks noGrp="1"/>
+            <a:spLocks noGrp="1" noRot="1" noChangeAspect="1"/>
           </p:cNvSpPr>
           <p:nvPr>
             <p:ph type="sldImg" idx="2"/>
@@ -507,7 +330,7 @@
             <a:spLocks noGrp="1"/>
           </p:cNvSpPr>
           <p:nvPr>
-            <p:ph type="body" idx="3" sz="quarter"/>
+            <p:ph type="body" sz="quarter" idx="3"/>
           </p:nvPr>
         </p:nvSpPr>
         <p:spPr/>
@@ -548,7 +371,7 @@
             <a:spLocks noGrp="1"/>
           </p:cNvSpPr>
           <p:nvPr>
-            <p:ph type="sldNum" idx="5" sz="quarter"/>
+            <p:ph type="sldNum" sz="quarter" idx="5"/>
           </p:nvPr>
         </p:nvSpPr>
         <p:spPr/>
@@ -562,7 +385,7 @@
 </file>
 
 <file path=ppt/notesSlides/notesSlide10.xml><?xml version="1.0" encoding="utf-8"?>
-<p:notes xmlns:a="http://schemas.openxmlformats.org/drawingml/2006/main" xmlns:p="http://schemas.openxmlformats.org/presentationml/2006/main" xmlns:r="http://schemas.openxmlformats.org/officeDocument/2006/relationships">
+<p:notes xmlns:a="http://schemas.openxmlformats.org/drawingml/2006/main" xmlns:r="http://schemas.openxmlformats.org/officeDocument/2006/relationships" xmlns:p="http://schemas.openxmlformats.org/presentationml/2006/main">
   <p:cSld>
     <p:spTree>
       <p:nvGrpSpPr>
@@ -582,7 +405,7 @@
         <p:nvSpPr>
           <p:cNvPr id="2" name="Slide Image Placeholder 1"/>
           <p:cNvSpPr>
-            <a:spLocks noGrp="1"/>
+            <a:spLocks noGrp="1" noRot="1" noChangeAspect="1"/>
           </p:cNvSpPr>
           <p:nvPr>
             <p:ph type="sldImg" idx="2"/>
@@ -597,7 +420,7 @@
             <a:spLocks noGrp="1"/>
           </p:cNvSpPr>
           <p:nvPr>
-            <p:ph type="body" idx="3" sz="quarter"/>
+            <p:ph type="body" sz="quarter" idx="3"/>
           </p:nvPr>
         </p:nvSpPr>
         <p:spPr/>
@@ -638,7 +461,7 @@
             <a:spLocks noGrp="1"/>
           </p:cNvSpPr>
           <p:nvPr>
-            <p:ph type="sldNum" idx="5" sz="quarter"/>
+            <p:ph type="sldNum" sz="quarter" idx="5"/>
           </p:nvPr>
         </p:nvSpPr>
         <p:spPr/>
@@ -652,7 +475,7 @@
 </file>
 
 <file path=ppt/notesSlides/notesSlide11.xml><?xml version="1.0" encoding="utf-8"?>
-<p:notes xmlns:a="http://schemas.openxmlformats.org/drawingml/2006/main" xmlns:p="http://schemas.openxmlformats.org/presentationml/2006/main" xmlns:r="http://schemas.openxmlformats.org/officeDocument/2006/relationships">
+<p:notes xmlns:a="http://schemas.openxmlformats.org/drawingml/2006/main" xmlns:r="http://schemas.openxmlformats.org/officeDocument/2006/relationships" xmlns:p="http://schemas.openxmlformats.org/presentationml/2006/main">
   <p:cSld>
     <p:spTree>
       <p:nvGrpSpPr>
@@ -672,7 +495,7 @@
         <p:nvSpPr>
           <p:cNvPr id="2" name="Slide Image Placeholder 1"/>
           <p:cNvSpPr>
-            <a:spLocks noGrp="1"/>
+            <a:spLocks noGrp="1" noRot="1" noChangeAspect="1"/>
           </p:cNvSpPr>
           <p:nvPr>
             <p:ph type="sldImg" idx="2"/>
@@ -687,7 +510,7 @@
             <a:spLocks noGrp="1"/>
           </p:cNvSpPr>
           <p:nvPr>
-            <p:ph type="body" idx="3" sz="quarter"/>
+            <p:ph type="body" sz="quarter" idx="3"/>
           </p:nvPr>
         </p:nvSpPr>
         <p:spPr/>
@@ -723,7 +546,7 @@
             <a:spLocks noGrp="1"/>
           </p:cNvSpPr>
           <p:nvPr>
-            <p:ph type="sldNum" idx="5" sz="quarter"/>
+            <p:ph type="sldNum" sz="quarter" idx="5"/>
           </p:nvPr>
         </p:nvSpPr>
         <p:spPr/>
@@ -737,7 +560,7 @@
 </file>
 
 <file path=ppt/notesSlides/notesSlide12.xml><?xml version="1.0" encoding="utf-8"?>
-<p:notes xmlns:a="http://schemas.openxmlformats.org/drawingml/2006/main" xmlns:p="http://schemas.openxmlformats.org/presentationml/2006/main" xmlns:r="http://schemas.openxmlformats.org/officeDocument/2006/relationships">
+<p:notes xmlns:a="http://schemas.openxmlformats.org/drawingml/2006/main" xmlns:r="http://schemas.openxmlformats.org/officeDocument/2006/relationships" xmlns:p="http://schemas.openxmlformats.org/presentationml/2006/main">
   <p:cSld>
     <p:spTree>
       <p:nvGrpSpPr>
@@ -757,7 +580,7 @@
         <p:nvSpPr>
           <p:cNvPr id="2" name="Slide Image Placeholder 1"/>
           <p:cNvSpPr>
-            <a:spLocks noGrp="1"/>
+            <a:spLocks noGrp="1" noRot="1" noChangeAspect="1"/>
           </p:cNvSpPr>
           <p:nvPr>
             <p:ph type="sldImg" idx="2"/>
@@ -772,7 +595,7 @@
             <a:spLocks noGrp="1"/>
           </p:cNvSpPr>
           <p:nvPr>
-            <p:ph type="body" idx="3" sz="quarter"/>
+            <p:ph type="body" sz="quarter" idx="3"/>
           </p:nvPr>
         </p:nvSpPr>
         <p:spPr/>
@@ -813,7 +636,7 @@
             <a:spLocks noGrp="1"/>
           </p:cNvSpPr>
           <p:nvPr>
-            <p:ph type="sldNum" idx="5" sz="quarter"/>
+            <p:ph type="sldNum" sz="quarter" idx="5"/>
           </p:nvPr>
         </p:nvSpPr>
         <p:spPr/>
@@ -827,7 +650,7 @@
 </file>
 
 <file path=ppt/notesSlides/notesSlide13.xml><?xml version="1.0" encoding="utf-8"?>
-<p:notes xmlns:a="http://schemas.openxmlformats.org/drawingml/2006/main" xmlns:p="http://schemas.openxmlformats.org/presentationml/2006/main" xmlns:r="http://schemas.openxmlformats.org/officeDocument/2006/relationships">
+<p:notes xmlns:a="http://schemas.openxmlformats.org/drawingml/2006/main" xmlns:r="http://schemas.openxmlformats.org/officeDocument/2006/relationships" xmlns:p="http://schemas.openxmlformats.org/presentationml/2006/main">
   <p:cSld>
     <p:spTree>
       <p:nvGrpSpPr>
@@ -847,7 +670,7 @@
         <p:nvSpPr>
           <p:cNvPr id="2" name="Slide Image Placeholder 1"/>
           <p:cNvSpPr>
-            <a:spLocks noGrp="1"/>
+            <a:spLocks noGrp="1" noRot="1" noChangeAspect="1"/>
           </p:cNvSpPr>
           <p:nvPr>
             <p:ph type="sldImg" idx="2"/>
@@ -862,7 +685,7 @@
             <a:spLocks noGrp="1"/>
           </p:cNvSpPr>
           <p:nvPr>
-            <p:ph type="body" idx="3" sz="quarter"/>
+            <p:ph type="body" sz="quarter" idx="3"/>
           </p:nvPr>
         </p:nvSpPr>
         <p:spPr/>
@@ -903,7 +726,7 @@
             <a:spLocks noGrp="1"/>
           </p:cNvSpPr>
           <p:nvPr>
-            <p:ph type="sldNum" idx="5" sz="quarter"/>
+            <p:ph type="sldNum" sz="quarter" idx="5"/>
           </p:nvPr>
         </p:nvSpPr>
         <p:spPr/>
@@ -917,7 +740,7 @@
 </file>
 
 <file path=ppt/notesSlides/notesSlide14.xml><?xml version="1.0" encoding="utf-8"?>
-<p:notes xmlns:a="http://schemas.openxmlformats.org/drawingml/2006/main" xmlns:p="http://schemas.openxmlformats.org/presentationml/2006/main" xmlns:r="http://schemas.openxmlformats.org/officeDocument/2006/relationships">
+<p:notes xmlns:a="http://schemas.openxmlformats.org/drawingml/2006/main" xmlns:r="http://schemas.openxmlformats.org/officeDocument/2006/relationships" xmlns:p="http://schemas.openxmlformats.org/presentationml/2006/main">
   <p:cSld>
     <p:spTree>
       <p:nvGrpSpPr>
@@ -937,7 +760,7 @@
         <p:nvSpPr>
           <p:cNvPr id="2" name="Slide Image Placeholder 1"/>
           <p:cNvSpPr>
-            <a:spLocks noGrp="1"/>
+            <a:spLocks noGrp="1" noRot="1" noChangeAspect="1"/>
           </p:cNvSpPr>
           <p:nvPr>
             <p:ph type="sldImg" idx="2"/>
@@ -952,7 +775,7 @@
             <a:spLocks noGrp="1"/>
           </p:cNvSpPr>
           <p:nvPr>
-            <p:ph type="body" idx="3" sz="quarter"/>
+            <p:ph type="body" sz="quarter" idx="3"/>
           </p:nvPr>
         </p:nvSpPr>
         <p:spPr/>
@@ -998,7 +821,7 @@
             <a:spLocks noGrp="1"/>
           </p:cNvSpPr>
           <p:nvPr>
-            <p:ph type="sldNum" idx="5" sz="quarter"/>
+            <p:ph type="sldNum" sz="quarter" idx="5"/>
           </p:nvPr>
         </p:nvSpPr>
         <p:spPr/>
@@ -1012,7 +835,7 @@
 </file>
 
 <file path=ppt/notesSlides/notesSlide15.xml><?xml version="1.0" encoding="utf-8"?>
-<p:notes xmlns:a="http://schemas.openxmlformats.org/drawingml/2006/main" xmlns:p="http://schemas.openxmlformats.org/presentationml/2006/main" xmlns:r="http://schemas.openxmlformats.org/officeDocument/2006/relationships">
+<p:notes xmlns:a="http://schemas.openxmlformats.org/drawingml/2006/main" xmlns:r="http://schemas.openxmlformats.org/officeDocument/2006/relationships" xmlns:p="http://schemas.openxmlformats.org/presentationml/2006/main">
   <p:cSld>
     <p:spTree>
       <p:nvGrpSpPr>
@@ -1032,7 +855,7 @@
         <p:nvSpPr>
           <p:cNvPr id="2" name="Slide Image Placeholder 1"/>
           <p:cNvSpPr>
-            <a:spLocks noGrp="1"/>
+            <a:spLocks noGrp="1" noRot="1" noChangeAspect="1"/>
           </p:cNvSpPr>
           <p:nvPr>
             <p:ph type="sldImg" idx="2"/>
@@ -1047,7 +870,7 @@
             <a:spLocks noGrp="1"/>
           </p:cNvSpPr>
           <p:nvPr>
-            <p:ph type="body" idx="3" sz="quarter"/>
+            <p:ph type="body" sz="quarter" idx="3"/>
           </p:nvPr>
         </p:nvSpPr>
         <p:spPr/>
@@ -1098,7 +921,7 @@
             <a:spLocks noGrp="1"/>
           </p:cNvSpPr>
           <p:nvPr>
-            <p:ph type="sldNum" idx="5" sz="quarter"/>
+            <p:ph type="sldNum" sz="quarter" idx="5"/>
           </p:nvPr>
         </p:nvSpPr>
         <p:spPr/>
@@ -1112,7 +935,7 @@
 </file>
 
 <file path=ppt/notesSlides/notesSlide2.xml><?xml version="1.0" encoding="utf-8"?>
-<p:notes xmlns:a="http://schemas.openxmlformats.org/drawingml/2006/main" xmlns:p="http://schemas.openxmlformats.org/presentationml/2006/main" xmlns:r="http://schemas.openxmlformats.org/officeDocument/2006/relationships">
+<p:notes xmlns:a="http://schemas.openxmlformats.org/drawingml/2006/main" xmlns:r="http://schemas.openxmlformats.org/officeDocument/2006/relationships" xmlns:p="http://schemas.openxmlformats.org/presentationml/2006/main">
   <p:cSld>
     <p:spTree>
       <p:nvGrpSpPr>
@@ -1132,7 +955,7 @@
         <p:nvSpPr>
           <p:cNvPr id="2" name="Slide Image Placeholder 1"/>
           <p:cNvSpPr>
-            <a:spLocks noGrp="1"/>
+            <a:spLocks noGrp="1" noRot="1" noChangeAspect="1"/>
           </p:cNvSpPr>
           <p:nvPr>
             <p:ph type="sldImg" idx="2"/>
@@ -1147,7 +970,7 @@
             <a:spLocks noGrp="1"/>
           </p:cNvSpPr>
           <p:nvPr>
-            <p:ph type="body" idx="3" sz="quarter"/>
+            <p:ph type="body" sz="quarter" idx="3"/>
           </p:nvPr>
         </p:nvSpPr>
         <p:spPr/>
@@ -1188,7 +1011,7 @@
             <a:spLocks noGrp="1"/>
           </p:cNvSpPr>
           <p:nvPr>
-            <p:ph type="sldNum" idx="5" sz="quarter"/>
+            <p:ph type="sldNum" sz="quarter" idx="5"/>
           </p:nvPr>
         </p:nvSpPr>
         <p:spPr/>
@@ -1202,7 +1025,7 @@
 </file>
 
 <file path=ppt/notesSlides/notesSlide3.xml><?xml version="1.0" encoding="utf-8"?>
-<p:notes xmlns:a="http://schemas.openxmlformats.org/drawingml/2006/main" xmlns:p="http://schemas.openxmlformats.org/presentationml/2006/main" xmlns:r="http://schemas.openxmlformats.org/officeDocument/2006/relationships">
+<p:notes xmlns:a="http://schemas.openxmlformats.org/drawingml/2006/main" xmlns:r="http://schemas.openxmlformats.org/officeDocument/2006/relationships" xmlns:p="http://schemas.openxmlformats.org/presentationml/2006/main">
   <p:cSld>
     <p:spTree>
       <p:nvGrpSpPr>
@@ -1222,7 +1045,7 @@
         <p:nvSpPr>
           <p:cNvPr id="2" name="Slide Image Placeholder 1"/>
           <p:cNvSpPr>
-            <a:spLocks noGrp="1"/>
+            <a:spLocks noGrp="1" noRot="1" noChangeAspect="1"/>
           </p:cNvSpPr>
           <p:nvPr>
             <p:ph type="sldImg" idx="2"/>
@@ -1237,7 +1060,7 @@
             <a:spLocks noGrp="1"/>
           </p:cNvSpPr>
           <p:nvPr>
-            <p:ph type="body" idx="3" sz="quarter"/>
+            <p:ph type="body" sz="quarter" idx="3"/>
           </p:nvPr>
         </p:nvSpPr>
         <p:spPr/>
@@ -1278,7 +1101,7 @@
             <a:spLocks noGrp="1"/>
           </p:cNvSpPr>
           <p:nvPr>
-            <p:ph type="sldNum" idx="5" sz="quarter"/>
+            <p:ph type="sldNum" sz="quarter" idx="5"/>
           </p:nvPr>
         </p:nvSpPr>
         <p:spPr/>
@@ -1292,7 +1115,7 @@
 </file>
 
 <file path=ppt/notesSlides/notesSlide4.xml><?xml version="1.0" encoding="utf-8"?>
-<p:notes xmlns:a="http://schemas.openxmlformats.org/drawingml/2006/main" xmlns:p="http://schemas.openxmlformats.org/presentationml/2006/main" xmlns:r="http://schemas.openxmlformats.org/officeDocument/2006/relationships">
+<p:notes xmlns:a="http://schemas.openxmlformats.org/drawingml/2006/main" xmlns:r="http://schemas.openxmlformats.org/officeDocument/2006/relationships" xmlns:p="http://schemas.openxmlformats.org/presentationml/2006/main">
   <p:cSld>
     <p:spTree>
       <p:nvGrpSpPr>
@@ -1312,7 +1135,7 @@
         <p:nvSpPr>
           <p:cNvPr id="2" name="Slide Image Placeholder 1"/>
           <p:cNvSpPr>
-            <a:spLocks noGrp="1"/>
+            <a:spLocks noGrp="1" noRot="1" noChangeAspect="1"/>
           </p:cNvSpPr>
           <p:nvPr>
             <p:ph type="sldImg" idx="2"/>
@@ -1327,7 +1150,7 @@
             <a:spLocks noGrp="1"/>
           </p:cNvSpPr>
           <p:nvPr>
-            <p:ph type="body" idx="3" sz="quarter"/>
+            <p:ph type="body" sz="quarter" idx="3"/>
           </p:nvPr>
         </p:nvSpPr>
         <p:spPr/>
@@ -1368,7 +1191,7 @@
             <a:spLocks noGrp="1"/>
           </p:cNvSpPr>
           <p:nvPr>
-            <p:ph type="sldNum" idx="5" sz="quarter"/>
+            <p:ph type="sldNum" sz="quarter" idx="5"/>
           </p:nvPr>
         </p:nvSpPr>
         <p:spPr/>
@@ -1382,7 +1205,7 @@
 </file>
 
 <file path=ppt/notesSlides/notesSlide5.xml><?xml version="1.0" encoding="utf-8"?>
-<p:notes xmlns:a="http://schemas.openxmlformats.org/drawingml/2006/main" xmlns:p="http://schemas.openxmlformats.org/presentationml/2006/main" xmlns:r="http://schemas.openxmlformats.org/officeDocument/2006/relationships">
+<p:notes xmlns:a="http://schemas.openxmlformats.org/drawingml/2006/main" xmlns:r="http://schemas.openxmlformats.org/officeDocument/2006/relationships" xmlns:p="http://schemas.openxmlformats.org/presentationml/2006/main">
   <p:cSld>
     <p:spTree>
       <p:nvGrpSpPr>
@@ -1402,7 +1225,7 @@
         <p:nvSpPr>
           <p:cNvPr id="2" name="Slide Image Placeholder 1"/>
           <p:cNvSpPr>
-            <a:spLocks noGrp="1"/>
+            <a:spLocks noGrp="1" noRot="1" noChangeAspect="1"/>
           </p:cNvSpPr>
           <p:nvPr>
             <p:ph type="sldImg" idx="2"/>
@@ -1417,7 +1240,7 @@
             <a:spLocks noGrp="1"/>
           </p:cNvSpPr>
           <p:nvPr>
-            <p:ph type="body" idx="3" sz="quarter"/>
+            <p:ph type="body" sz="quarter" idx="3"/>
           </p:nvPr>
         </p:nvSpPr>
         <p:spPr/>
@@ -1468,7 +1291,7 @@
             <a:spLocks noGrp="1"/>
           </p:cNvSpPr>
           <p:nvPr>
-            <p:ph type="sldNum" idx="5" sz="quarter"/>
+            <p:ph type="sldNum" sz="quarter" idx="5"/>
           </p:nvPr>
         </p:nvSpPr>
         <p:spPr/>
@@ -1482,7 +1305,7 @@
 </file>
 
 <file path=ppt/notesSlides/notesSlide6.xml><?xml version="1.0" encoding="utf-8"?>
-<p:notes xmlns:a="http://schemas.openxmlformats.org/drawingml/2006/main" xmlns:p="http://schemas.openxmlformats.org/presentationml/2006/main" xmlns:r="http://schemas.openxmlformats.org/officeDocument/2006/relationships">
+<p:notes xmlns:a="http://schemas.openxmlformats.org/drawingml/2006/main" xmlns:r="http://schemas.openxmlformats.org/officeDocument/2006/relationships" xmlns:p="http://schemas.openxmlformats.org/presentationml/2006/main">
   <p:cSld>
     <p:spTree>
       <p:nvGrpSpPr>
@@ -1502,7 +1325,7 @@
         <p:nvSpPr>
           <p:cNvPr id="2" name="Slide Image Placeholder 1"/>
           <p:cNvSpPr>
-            <a:spLocks noGrp="1"/>
+            <a:spLocks noGrp="1" noRot="1" noChangeAspect="1"/>
           </p:cNvSpPr>
           <p:nvPr>
             <p:ph type="sldImg" idx="2"/>
@@ -1517,7 +1340,7 @@
             <a:spLocks noGrp="1"/>
           </p:cNvSpPr>
           <p:nvPr>
-            <p:ph type="body" idx="3" sz="quarter"/>
+            <p:ph type="body" sz="quarter" idx="3"/>
           </p:nvPr>
         </p:nvSpPr>
         <p:spPr/>
@@ -1553,7 +1376,7 @@
             <a:spLocks noGrp="1"/>
           </p:cNvSpPr>
           <p:nvPr>
-            <p:ph type="sldNum" idx="5" sz="quarter"/>
+            <p:ph type="sldNum" sz="quarter" idx="5"/>
           </p:nvPr>
         </p:nvSpPr>
         <p:spPr/>
@@ -1567,7 +1390,7 @@
 </file>
 
 <file path=ppt/notesSlides/notesSlide7.xml><?xml version="1.0" encoding="utf-8"?>
-<p:notes xmlns:a="http://schemas.openxmlformats.org/drawingml/2006/main" xmlns:p="http://schemas.openxmlformats.org/presentationml/2006/main" xmlns:r="http://schemas.openxmlformats.org/officeDocument/2006/relationships">
+<p:notes xmlns:a="http://schemas.openxmlformats.org/drawingml/2006/main" xmlns:r="http://schemas.openxmlformats.org/officeDocument/2006/relationships" xmlns:p="http://schemas.openxmlformats.org/presentationml/2006/main">
   <p:cSld>
     <p:spTree>
       <p:nvGrpSpPr>
@@ -1587,7 +1410,7 @@
         <p:nvSpPr>
           <p:cNvPr id="2" name="Slide Image Placeholder 1"/>
           <p:cNvSpPr>
-            <a:spLocks noGrp="1"/>
+            <a:spLocks noGrp="1" noRot="1" noChangeAspect="1"/>
           </p:cNvSpPr>
           <p:nvPr>
             <p:ph type="sldImg" idx="2"/>
@@ -1602,7 +1425,7 @@
             <a:spLocks noGrp="1"/>
           </p:cNvSpPr>
           <p:nvPr>
-            <p:ph type="body" idx="3" sz="quarter"/>
+            <p:ph type="body" sz="quarter" idx="3"/>
           </p:nvPr>
         </p:nvSpPr>
         <p:spPr/>
@@ -1643,7 +1466,7 @@
             <a:spLocks noGrp="1"/>
           </p:cNvSpPr>
           <p:nvPr>
-            <p:ph type="sldNum" idx="5" sz="quarter"/>
+            <p:ph type="sldNum" sz="quarter" idx="5"/>
           </p:nvPr>
         </p:nvSpPr>
         <p:spPr/>
@@ -1657,7 +1480,7 @@
 </file>
 
 <file path=ppt/notesSlides/notesSlide8.xml><?xml version="1.0" encoding="utf-8"?>
-<p:notes xmlns:a="http://schemas.openxmlformats.org/drawingml/2006/main" xmlns:p="http://schemas.openxmlformats.org/presentationml/2006/main" xmlns:r="http://schemas.openxmlformats.org/officeDocument/2006/relationships">
+<p:notes xmlns:a="http://schemas.openxmlformats.org/drawingml/2006/main" xmlns:r="http://schemas.openxmlformats.org/officeDocument/2006/relationships" xmlns:p="http://schemas.openxmlformats.org/presentationml/2006/main">
   <p:cSld>
     <p:spTree>
       <p:nvGrpSpPr>
@@ -1677,7 +1500,7 @@
         <p:nvSpPr>
           <p:cNvPr id="2" name="Slide Image Placeholder 1"/>
           <p:cNvSpPr>
-            <a:spLocks noGrp="1"/>
+            <a:spLocks noGrp="1" noRot="1" noChangeAspect="1"/>
           </p:cNvSpPr>
           <p:nvPr>
             <p:ph type="sldImg" idx="2"/>
@@ -1692,7 +1515,7 @@
             <a:spLocks noGrp="1"/>
           </p:cNvSpPr>
           <p:nvPr>
-            <p:ph type="body" idx="3" sz="quarter"/>
+            <p:ph type="body" sz="quarter" idx="3"/>
           </p:nvPr>
         </p:nvSpPr>
         <p:spPr/>
@@ -1733,7 +1556,7 @@
             <a:spLocks noGrp="1"/>
           </p:cNvSpPr>
           <p:nvPr>
-            <p:ph type="sldNum" idx="5" sz="quarter"/>
+            <p:ph type="sldNum" sz="quarter" idx="5"/>
           </p:nvPr>
         </p:nvSpPr>
         <p:spPr/>
@@ -1747,7 +1570,7 @@
 </file>
 
 <file path=ppt/notesSlides/notesSlide9.xml><?xml version="1.0" encoding="utf-8"?>
-<p:notes xmlns:a="http://schemas.openxmlformats.org/drawingml/2006/main" xmlns:p="http://schemas.openxmlformats.org/presentationml/2006/main" xmlns:r="http://schemas.openxmlformats.org/officeDocument/2006/relationships">
+<p:notes xmlns:a="http://schemas.openxmlformats.org/drawingml/2006/main" xmlns:r="http://schemas.openxmlformats.org/officeDocument/2006/relationships" xmlns:p="http://schemas.openxmlformats.org/presentationml/2006/main">
   <p:cSld>
     <p:spTree>
       <p:nvGrpSpPr>
@@ -1767,7 +1590,7 @@
         <p:nvSpPr>
           <p:cNvPr id="2" name="Slide Image Placeholder 1"/>
           <p:cNvSpPr>
-            <a:spLocks noGrp="1"/>
+            <a:spLocks noGrp="1" noRot="1" noChangeAspect="1"/>
           </p:cNvSpPr>
           <p:nvPr>
             <p:ph type="sldImg" idx="2"/>
@@ -1782,7 +1605,7 @@
             <a:spLocks noGrp="1"/>
           </p:cNvSpPr>
           <p:nvPr>
-            <p:ph type="body" idx="3" sz="quarter"/>
+            <p:ph type="body" sz="quarter" idx="3"/>
           </p:nvPr>
         </p:nvSpPr>
         <p:spPr/>
@@ -1823,7 +1646,7 @@
             <a:spLocks noGrp="1"/>
           </p:cNvSpPr>
           <p:nvPr>
-            <p:ph type="sldNum" idx="5" sz="quarter"/>
+            <p:ph type="sldNum" sz="quarter" idx="5"/>
           </p:nvPr>
         </p:nvSpPr>
         <p:spPr/>
@@ -1874,10 +1697,9 @@
           <a:lstStyle/>
           <a:p>
             <a:r>
-              <a:rPr lang="en-US" smtClean="0"/>
+              <a:rPr lang="en-US"/>
               <a:t>Click to edit Master title style</a:t>
             </a:r>
-            <a:endParaRPr lang="en-US"/>
           </a:p>
         </p:txBody>
       </p:sp>
@@ -1993,10 +1815,9 @@
           </a:lstStyle>
           <a:p>
             <a:r>
-              <a:rPr lang="en-US" smtClean="0"/>
+              <a:rPr lang="en-US"/>
               <a:t>Click to edit Master subtitle style</a:t>
             </a:r>
-            <a:endParaRPr lang="en-US"/>
           </a:p>
         </p:txBody>
       </p:sp>
@@ -2017,7 +1838,7 @@
           <a:p>
             <a:fld id="{5BCAD085-E8A6-8845-BD4E-CB4CCA059FC4}" type="datetimeFigureOut">
               <a:rPr lang="en-US" smtClean="0"/>
-              <a:t>1/27/13</a:t>
+              <a:t>10/22/2026</a:t>
             </a:fld>
             <a:endParaRPr lang="en-US"/>
           </a:p>
@@ -2111,10 +1932,9 @@
           <a:lstStyle/>
           <a:p>
             <a:r>
-              <a:rPr lang="en-US" smtClean="0"/>
+              <a:rPr lang="en-US"/>
               <a:t>Click to edit Master title style</a:t>
             </a:r>
-            <a:endParaRPr lang="en-US"/>
           </a:p>
         </p:txBody>
       </p:sp>
@@ -2135,38 +1955,37 @@
           <a:p>
             <a:pPr lvl="0"/>
             <a:r>
-              <a:rPr lang="en-US" smtClean="0"/>
+              <a:rPr lang="en-US"/>
               <a:t>Click to edit Master text styles</a:t>
             </a:r>
           </a:p>
           <a:p>
             <a:pPr lvl="1"/>
             <a:r>
-              <a:rPr lang="en-US" smtClean="0"/>
+              <a:rPr lang="en-US"/>
               <a:t>Second level</a:t>
             </a:r>
           </a:p>
           <a:p>
             <a:pPr lvl="2"/>
             <a:r>
-              <a:rPr lang="en-US" smtClean="0"/>
+              <a:rPr lang="en-US"/>
               <a:t>Third level</a:t>
             </a:r>
           </a:p>
           <a:p>
             <a:pPr lvl="3"/>
             <a:r>
-              <a:rPr lang="en-US" smtClean="0"/>
+              <a:rPr lang="en-US"/>
               <a:t>Fourth level</a:t>
             </a:r>
           </a:p>
           <a:p>
             <a:pPr lvl="4"/>
             <a:r>
-              <a:rPr lang="en-US" smtClean="0"/>
+              <a:rPr lang="en-US"/>
               <a:t>Fifth level</a:t>
             </a:r>
-            <a:endParaRPr lang="en-US"/>
           </a:p>
         </p:txBody>
       </p:sp>
@@ -2187,7 +2006,7 @@
           <a:p>
             <a:fld id="{5BCAD085-E8A6-8845-BD4E-CB4CCA059FC4}" type="datetimeFigureOut">
               <a:rPr lang="en-US" smtClean="0"/>
-              <a:t>1/27/13</a:t>
+              <a:t>10/22/2026</a:t>
             </a:fld>
             <a:endParaRPr lang="en-US"/>
           </a:p>
@@ -2286,10 +2105,9 @@
           <a:lstStyle/>
           <a:p>
             <a:r>
-              <a:rPr lang="en-US" smtClean="0"/>
+              <a:rPr lang="en-US"/>
               <a:t>Click to edit Master title style</a:t>
             </a:r>
-            <a:endParaRPr lang="en-US"/>
           </a:p>
         </p:txBody>
       </p:sp>
@@ -2315,38 +2133,37 @@
           <a:p>
             <a:pPr lvl="0"/>
             <a:r>
-              <a:rPr lang="en-US" smtClean="0"/>
+              <a:rPr lang="en-US"/>
               <a:t>Click to edit Master text styles</a:t>
             </a:r>
           </a:p>
           <a:p>
             <a:pPr lvl="1"/>
             <a:r>
-              <a:rPr lang="en-US" smtClean="0"/>
+              <a:rPr lang="en-US"/>
               <a:t>Second level</a:t>
             </a:r>
           </a:p>
           <a:p>
             <a:pPr lvl="2"/>
             <a:r>
-              <a:rPr lang="en-US" smtClean="0"/>
+              <a:rPr lang="en-US"/>
               <a:t>Third level</a:t>
             </a:r>
           </a:p>
           <a:p>
             <a:pPr lvl="3"/>
             <a:r>
-              <a:rPr lang="en-US" smtClean="0"/>
+              <a:rPr lang="en-US"/>
               <a:t>Fourth level</a:t>
             </a:r>
           </a:p>
           <a:p>
             <a:pPr lvl="4"/>
             <a:r>
-              <a:rPr lang="en-US" smtClean="0"/>
+              <a:rPr lang="en-US"/>
               <a:t>Fifth level</a:t>
             </a:r>
-            <a:endParaRPr lang="en-US"/>
           </a:p>
         </p:txBody>
       </p:sp>
@@ -2367,7 +2184,7 @@
           <a:p>
             <a:fld id="{5BCAD085-E8A6-8845-BD4E-CB4CCA059FC4}" type="datetimeFigureOut">
               <a:rPr lang="en-US" smtClean="0"/>
-              <a:t>1/27/13</a:t>
+              <a:t>10/22/2026</a:t>
             </a:fld>
             <a:endParaRPr lang="en-US"/>
           </a:p>
@@ -2461,10 +2278,9 @@
           <a:lstStyle/>
           <a:p>
             <a:r>
-              <a:rPr lang="en-US" smtClean="0"/>
+              <a:rPr lang="en-US"/>
               <a:t>Click to edit Master title style</a:t>
             </a:r>
-            <a:endParaRPr lang="en-US"/>
           </a:p>
         </p:txBody>
       </p:sp>
@@ -2485,38 +2301,37 @@
           <a:p>
             <a:pPr lvl="0"/>
             <a:r>
-              <a:rPr lang="en-US" smtClean="0"/>
+              <a:rPr lang="en-US"/>
               <a:t>Click to edit Master text styles</a:t>
             </a:r>
           </a:p>
           <a:p>
             <a:pPr lvl="1"/>
             <a:r>
-              <a:rPr lang="en-US" smtClean="0"/>
+              <a:rPr lang="en-US"/>
               <a:t>Second level</a:t>
             </a:r>
           </a:p>
           <a:p>
             <a:pPr lvl="2"/>
             <a:r>
-              <a:rPr lang="en-US" smtClean="0"/>
+              <a:rPr lang="en-US"/>
               <a:t>Third level</a:t>
             </a:r>
           </a:p>
           <a:p>
             <a:pPr lvl="3"/>
             <a:r>
-              <a:rPr lang="en-US" smtClean="0"/>
+              <a:rPr lang="en-US"/>
               <a:t>Fourth level</a:t>
             </a:r>
           </a:p>
           <a:p>
             <a:pPr lvl="4"/>
             <a:r>
-              <a:rPr lang="en-US" smtClean="0"/>
+              <a:rPr lang="en-US"/>
               <a:t>Fifth level</a:t>
             </a:r>
-            <a:endParaRPr lang="en-US"/>
           </a:p>
         </p:txBody>
       </p:sp>
@@ -2537,7 +2352,7 @@
           <a:p>
             <a:fld id="{5BCAD085-E8A6-8845-BD4E-CB4CCA059FC4}" type="datetimeFigureOut">
               <a:rPr lang="en-US" smtClean="0"/>
-              <a:t>1/27/13</a:t>
+              <a:t>10/22/2026</a:t>
             </a:fld>
             <a:endParaRPr lang="en-US"/>
           </a:p>
@@ -2640,10 +2455,9 @@
           </a:lstStyle>
           <a:p>
             <a:r>
-              <a:rPr lang="en-US" smtClean="0"/>
+              <a:rPr lang="en-US"/>
               <a:t>Click to edit Master title style</a:t>
             </a:r>
-            <a:endParaRPr lang="en-US"/>
           </a:p>
         </p:txBody>
       </p:sp>
@@ -2760,7 +2574,7 @@
           <a:p>
             <a:pPr lvl="0"/>
             <a:r>
-              <a:rPr lang="en-US" smtClean="0"/>
+              <a:rPr lang="en-US"/>
               <a:t>Click to edit Master text styles</a:t>
             </a:r>
           </a:p>
@@ -2783,7 +2597,7 @@
           <a:p>
             <a:fld id="{5BCAD085-E8A6-8845-BD4E-CB4CCA059FC4}" type="datetimeFigureOut">
               <a:rPr lang="en-US" smtClean="0"/>
-              <a:t>1/27/13</a:t>
+              <a:t>10/22/2026</a:t>
             </a:fld>
             <a:endParaRPr lang="en-US"/>
           </a:p>
@@ -2877,10 +2691,9 @@
           <a:lstStyle/>
           <a:p>
             <a:r>
-              <a:rPr lang="en-US" smtClean="0"/>
+              <a:rPr lang="en-US"/>
               <a:t>Click to edit Master title style</a:t>
             </a:r>
-            <a:endParaRPr lang="en-US"/>
           </a:p>
         </p:txBody>
       </p:sp>
@@ -2934,38 +2747,37 @@
           <a:p>
             <a:pPr lvl="0"/>
             <a:r>
-              <a:rPr lang="en-US" smtClean="0"/>
+              <a:rPr lang="en-US"/>
               <a:t>Click to edit Master text styles</a:t>
             </a:r>
           </a:p>
           <a:p>
             <a:pPr lvl="1"/>
             <a:r>
-              <a:rPr lang="en-US" smtClean="0"/>
+              <a:rPr lang="en-US"/>
               <a:t>Second level</a:t>
             </a:r>
           </a:p>
           <a:p>
             <a:pPr lvl="2"/>
             <a:r>
-              <a:rPr lang="en-US" smtClean="0"/>
+              <a:rPr lang="en-US"/>
               <a:t>Third level</a:t>
             </a:r>
           </a:p>
           <a:p>
             <a:pPr lvl="3"/>
             <a:r>
-              <a:rPr lang="en-US" smtClean="0"/>
+              <a:rPr lang="en-US"/>
               <a:t>Fourth level</a:t>
             </a:r>
           </a:p>
           <a:p>
             <a:pPr lvl="4"/>
             <a:r>
-              <a:rPr lang="en-US" smtClean="0"/>
+              <a:rPr lang="en-US"/>
               <a:t>Fifth level</a:t>
             </a:r>
-            <a:endParaRPr lang="en-US"/>
           </a:p>
         </p:txBody>
       </p:sp>
@@ -3019,38 +2831,37 @@
           <a:p>
             <a:pPr lvl="0"/>
             <a:r>
-              <a:rPr lang="en-US" smtClean="0"/>
+              <a:rPr lang="en-US"/>
               <a:t>Click to edit Master text styles</a:t>
             </a:r>
           </a:p>
           <a:p>
             <a:pPr lvl="1"/>
             <a:r>
-              <a:rPr lang="en-US" smtClean="0"/>
+              <a:rPr lang="en-US"/>
               <a:t>Second level</a:t>
             </a:r>
           </a:p>
           <a:p>
             <a:pPr lvl="2"/>
             <a:r>
-              <a:rPr lang="en-US" smtClean="0"/>
+              <a:rPr lang="en-US"/>
               <a:t>Third level</a:t>
             </a:r>
           </a:p>
           <a:p>
             <a:pPr lvl="3"/>
             <a:r>
-              <a:rPr lang="en-US" smtClean="0"/>
+              <a:rPr lang="en-US"/>
               <a:t>Fourth level</a:t>
             </a:r>
           </a:p>
           <a:p>
             <a:pPr lvl="4"/>
             <a:r>
-              <a:rPr lang="en-US" smtClean="0"/>
+              <a:rPr lang="en-US"/>
               <a:t>Fifth level</a:t>
             </a:r>
-            <a:endParaRPr lang="en-US"/>
           </a:p>
         </p:txBody>
       </p:sp>
@@ -3071,7 +2882,7 @@
           <a:p>
             <a:fld id="{5BCAD085-E8A6-8845-BD4E-CB4CCA059FC4}" type="datetimeFigureOut">
               <a:rPr lang="en-US" smtClean="0"/>
-              <a:t>1/27/13</a:t>
+              <a:t>10/22/2026</a:t>
             </a:fld>
             <a:endParaRPr lang="en-US"/>
           </a:p>
@@ -3169,10 +2980,9 @@
           </a:lstStyle>
           <a:p>
             <a:r>
-              <a:rPr lang="en-US" smtClean="0"/>
+              <a:rPr lang="en-US"/>
               <a:t>Click to edit Master title style</a:t>
             </a:r>
-            <a:endParaRPr lang="en-US"/>
           </a:p>
         </p:txBody>
       </p:sp>
@@ -3235,7 +3045,7 @@
           <a:p>
             <a:pPr lvl="0"/>
             <a:r>
-              <a:rPr lang="en-US" smtClean="0"/>
+              <a:rPr lang="en-US"/>
               <a:t>Click to edit Master text styles</a:t>
             </a:r>
           </a:p>
@@ -3291,38 +3101,37 @@
           <a:p>
             <a:pPr lvl="0"/>
             <a:r>
-              <a:rPr lang="en-US" smtClean="0"/>
+              <a:rPr lang="en-US"/>
               <a:t>Click to edit Master text styles</a:t>
             </a:r>
           </a:p>
           <a:p>
             <a:pPr lvl="1"/>
             <a:r>
-              <a:rPr lang="en-US" smtClean="0"/>
+              <a:rPr lang="en-US"/>
               <a:t>Second level</a:t>
             </a:r>
           </a:p>
           <a:p>
             <a:pPr lvl="2"/>
             <a:r>
-              <a:rPr lang="en-US" smtClean="0"/>
+              <a:rPr lang="en-US"/>
               <a:t>Third level</a:t>
             </a:r>
           </a:p>
           <a:p>
             <a:pPr lvl="3"/>
             <a:r>
-              <a:rPr lang="en-US" smtClean="0"/>
+              <a:rPr lang="en-US"/>
               <a:t>Fourth level</a:t>
             </a:r>
           </a:p>
           <a:p>
             <a:pPr lvl="4"/>
             <a:r>
-              <a:rPr lang="en-US" smtClean="0"/>
+              <a:rPr lang="en-US"/>
               <a:t>Fifth level</a:t>
             </a:r>
-            <a:endParaRPr lang="en-US"/>
           </a:p>
         </p:txBody>
       </p:sp>
@@ -3385,7 +3194,7 @@
           <a:p>
             <a:pPr lvl="0"/>
             <a:r>
-              <a:rPr lang="en-US" smtClean="0"/>
+              <a:rPr lang="en-US"/>
               <a:t>Click to edit Master text styles</a:t>
             </a:r>
           </a:p>
@@ -3441,38 +3250,37 @@
           <a:p>
             <a:pPr lvl="0"/>
             <a:r>
-              <a:rPr lang="en-US" smtClean="0"/>
+              <a:rPr lang="en-US"/>
               <a:t>Click to edit Master text styles</a:t>
             </a:r>
           </a:p>
           <a:p>
             <a:pPr lvl="1"/>
             <a:r>
-              <a:rPr lang="en-US" smtClean="0"/>
+              <a:rPr lang="en-US"/>
               <a:t>Second level</a:t>
             </a:r>
           </a:p>
           <a:p>
             <a:pPr lvl="2"/>
             <a:r>
-              <a:rPr lang="en-US" smtClean="0"/>
+              <a:rPr lang="en-US"/>
               <a:t>Third level</a:t>
             </a:r>
           </a:p>
           <a:p>
             <a:pPr lvl="3"/>
             <a:r>
-              <a:rPr lang="en-US" smtClean="0"/>
+              <a:rPr lang="en-US"/>
               <a:t>Fourth level</a:t>
             </a:r>
           </a:p>
           <a:p>
             <a:pPr lvl="4"/>
             <a:r>
-              <a:rPr lang="en-US" smtClean="0"/>
+              <a:rPr lang="en-US"/>
               <a:t>Fifth level</a:t>
             </a:r>
-            <a:endParaRPr lang="en-US"/>
           </a:p>
         </p:txBody>
       </p:sp>
@@ -3493,7 +3301,7 @@
           <a:p>
             <a:fld id="{5BCAD085-E8A6-8845-BD4E-CB4CCA059FC4}" type="datetimeFigureOut">
               <a:rPr lang="en-US" smtClean="0"/>
-              <a:t>1/27/13</a:t>
+              <a:t>10/22/2026</a:t>
             </a:fld>
             <a:endParaRPr lang="en-US"/>
           </a:p>
@@ -3587,10 +3395,9 @@
           <a:lstStyle/>
           <a:p>
             <a:r>
-              <a:rPr lang="en-US" smtClean="0"/>
+              <a:rPr lang="en-US"/>
               <a:t>Click to edit Master title style</a:t>
             </a:r>
-            <a:endParaRPr lang="en-US"/>
           </a:p>
         </p:txBody>
       </p:sp>
@@ -3611,7 +3418,7 @@
           <a:p>
             <a:fld id="{5BCAD085-E8A6-8845-BD4E-CB4CCA059FC4}" type="datetimeFigureOut">
               <a:rPr lang="en-US" smtClean="0"/>
-              <a:t>1/27/13</a:t>
+              <a:t>10/22/2026</a:t>
             </a:fld>
             <a:endParaRPr lang="en-US"/>
           </a:p>
@@ -3706,7 +3513,7 @@
           <a:p>
             <a:fld id="{5BCAD085-E8A6-8845-BD4E-CB4CCA059FC4}" type="datetimeFigureOut">
               <a:rPr lang="en-US" smtClean="0"/>
-              <a:t>1/27/13</a:t>
+              <a:t>10/22/2026</a:t>
             </a:fld>
             <a:endParaRPr lang="en-US"/>
           </a:p>
@@ -3809,10 +3616,9 @@
           </a:lstStyle>
           <a:p>
             <a:r>
-              <a:rPr lang="en-US" smtClean="0"/>
+              <a:rPr lang="en-US"/>
               <a:t>Click to edit Master title style</a:t>
             </a:r>
-            <a:endParaRPr lang="en-US"/>
           </a:p>
         </p:txBody>
       </p:sp>
@@ -3866,38 +3672,37 @@
           <a:p>
             <a:pPr lvl="0"/>
             <a:r>
-              <a:rPr lang="en-US" smtClean="0"/>
+              <a:rPr lang="en-US"/>
               <a:t>Click to edit Master text styles</a:t>
             </a:r>
           </a:p>
           <a:p>
             <a:pPr lvl="1"/>
             <a:r>
-              <a:rPr lang="en-US" smtClean="0"/>
+              <a:rPr lang="en-US"/>
               <a:t>Second level</a:t>
             </a:r>
           </a:p>
           <a:p>
             <a:pPr lvl="2"/>
             <a:r>
-              <a:rPr lang="en-US" smtClean="0"/>
+              <a:rPr lang="en-US"/>
               <a:t>Third level</a:t>
             </a:r>
           </a:p>
           <a:p>
             <a:pPr lvl="3"/>
             <a:r>
-              <a:rPr lang="en-US" smtClean="0"/>
+              <a:rPr lang="en-US"/>
               <a:t>Fourth level</a:t>
             </a:r>
           </a:p>
           <a:p>
             <a:pPr lvl="4"/>
             <a:r>
-              <a:rPr lang="en-US" smtClean="0"/>
+              <a:rPr lang="en-US"/>
               <a:t>Fifth level</a:t>
             </a:r>
-            <a:endParaRPr lang="en-US"/>
           </a:p>
         </p:txBody>
       </p:sp>
@@ -3960,7 +3765,7 @@
           <a:p>
             <a:pPr lvl="0"/>
             <a:r>
-              <a:rPr lang="en-US" smtClean="0"/>
+              <a:rPr lang="en-US"/>
               <a:t>Click to edit Master text styles</a:t>
             </a:r>
           </a:p>
@@ -3983,7 +3788,7 @@
           <a:p>
             <a:fld id="{5BCAD085-E8A6-8845-BD4E-CB4CCA059FC4}" type="datetimeFigureOut">
               <a:rPr lang="en-US" smtClean="0"/>
-              <a:t>1/27/13</a:t>
+              <a:t>10/22/2026</a:t>
             </a:fld>
             <a:endParaRPr lang="en-US"/>
           </a:p>
@@ -4086,10 +3891,9 @@
           </a:lstStyle>
           <a:p>
             <a:r>
-              <a:rPr lang="en-US" smtClean="0"/>
+              <a:rPr lang="en-US"/>
               <a:t>Click to edit Master title style</a:t>
             </a:r>
-            <a:endParaRPr lang="en-US"/>
           </a:p>
         </p:txBody>
       </p:sp>
@@ -4213,7 +4017,7 @@
           <a:p>
             <a:pPr lvl="0"/>
             <a:r>
-              <a:rPr lang="en-US" smtClean="0"/>
+              <a:rPr lang="en-US"/>
               <a:t>Click to edit Master text styles</a:t>
             </a:r>
           </a:p>
@@ -4236,7 +4040,7 @@
           <a:p>
             <a:fld id="{5BCAD085-E8A6-8845-BD4E-CB4CCA059FC4}" type="datetimeFigureOut">
               <a:rPr lang="en-US" smtClean="0"/>
-              <a:t>1/27/13</a:t>
+              <a:t>10/22/2026</a:t>
             </a:fld>
             <a:endParaRPr lang="en-US"/>
           </a:p>
@@ -4345,10 +4149,9 @@
           <a:lstStyle/>
           <a:p>
             <a:r>
-              <a:rPr lang="en-US" smtClean="0"/>
+              <a:rPr lang="en-US"/>
               <a:t>Click to edit Master title style</a:t>
             </a:r>
-            <a:endParaRPr lang="en-US"/>
           </a:p>
         </p:txBody>
       </p:sp>
@@ -4379,38 +4182,37 @@
           <a:p>
             <a:pPr lvl="0"/>
             <a:r>
-              <a:rPr lang="en-US" smtClean="0"/>
+              <a:rPr lang="en-US"/>
               <a:t>Click to edit Master text styles</a:t>
             </a:r>
           </a:p>
           <a:p>
             <a:pPr lvl="1"/>
             <a:r>
-              <a:rPr lang="en-US" smtClean="0"/>
+              <a:rPr lang="en-US"/>
               <a:t>Second level</a:t>
             </a:r>
           </a:p>
           <a:p>
             <a:pPr lvl="2"/>
             <a:r>
-              <a:rPr lang="en-US" smtClean="0"/>
+              <a:rPr lang="en-US"/>
               <a:t>Third level</a:t>
             </a:r>
           </a:p>
           <a:p>
             <a:pPr lvl="3"/>
             <a:r>
-              <a:rPr lang="en-US" smtClean="0"/>
+              <a:rPr lang="en-US"/>
               <a:t>Fourth level</a:t>
             </a:r>
           </a:p>
           <a:p>
             <a:pPr lvl="4"/>
             <a:r>
-              <a:rPr lang="en-US" smtClean="0"/>
+              <a:rPr lang="en-US"/>
               <a:t>Fifth level</a:t>
             </a:r>
-            <a:endParaRPr lang="en-US"/>
           </a:p>
         </p:txBody>
       </p:sp>
@@ -4449,7 +4251,7 @@
           <a:p>
             <a:fld id="{5BCAD085-E8A6-8845-BD4E-CB4CCA059FC4}" type="datetimeFigureOut">
               <a:rPr lang="en-US" smtClean="0"/>
-              <a:t>1/27/13</a:t>
+              <a:t>10/22/2026</a:t>
             </a:fld>
             <a:endParaRPr lang="en-US"/>
           </a:p>
@@ -4808,7 +4610,7 @@
 </file>
 
 <file path=ppt/slides/slide1.xml><?xml version="1.0" encoding="utf-8"?>
-<p:sld xmlns:a="http://schemas.openxmlformats.org/drawingml/2006/main" xmlns:p="http://schemas.openxmlformats.org/presentationml/2006/main" xmlns:r="http://schemas.openxmlformats.org/officeDocument/2006/relationships">
+<p:sld xmlns:a="http://schemas.openxmlformats.org/drawingml/2006/main" xmlns:r="http://schemas.openxmlformats.org/officeDocument/2006/relationships" xmlns:p="http://schemas.openxmlformats.org/presentationml/2006/main">
   <p:cSld>
     <p:spTree>
       <p:nvGrpSpPr>
@@ -4816,7 +4618,14 @@
         <p:cNvGrpSpPr/>
         <p:nvPr/>
       </p:nvGrpSpPr>
-      <p:grpSpPr/>
+      <p:grpSpPr>
+        <a:xfrm>
+          <a:off x="0" y="0"/>
+          <a:ext cx="0" cy="0"/>
+          <a:chOff x="0" y="0"/>
+          <a:chExt cx="0" cy="0"/>
+        </a:xfrm>
+      </p:grpSpPr>
       <p:sp>
         <p:nvSpPr>
           <p:cNvPr id="2" name="Rectangle 1"/>
@@ -4857,6 +4666,7 @@
           <a:lstStyle/>
           <a:p>
             <a:pPr algn="ctr"/>
+            <a:endParaRPr/>
           </a:p>
         </p:txBody>
       </p:sp>
@@ -4902,6 +4712,7 @@
           <a:lstStyle/>
           <a:p>
             <a:pPr algn="ctr"/>
+            <a:endParaRPr/>
           </a:p>
         </p:txBody>
       </p:sp>
@@ -4913,8 +4724,8 @@
         </p:nvSpPr>
         <p:spPr>
           <a:xfrm>
-            <a:off x="1645920" y="1280160"/>
-            <a:ext cx="8869680" cy="4297680"/>
+            <a:off x="1645920" y="1097280"/>
+            <a:ext cx="9011920" cy="4339650"/>
           </a:xfrm>
           <a:prstGeom prst="rect">
             <a:avLst/>
@@ -4928,21 +4739,6 @@
           <a:lstStyle/>
           <a:p>
             <a:pPr>
-              <a:spcAft>
-                <a:spcPts val="1000"/>
-              </a:spcAft>
-              <a:defRPr sz="1100" b="1">
-                <a:solidFill>
-                  <a:srgbClr val="D97706"/>
-                </a:solidFill>
-              </a:defRPr>
-            </a:pPr>
-            <a:r>
-              <a:t>FINTECH REGTECH &amp; UNIVERSITY INNOVATION PITCH</a:t>
-            </a:r>
-          </a:p>
-          <a:p>
-            <a:pPr>
               <a:defRPr sz="4800" b="1">
                 <a:solidFill>
                   <a:srgbClr val="0E1726"/>
@@ -4950,6 +4746,9 @@
               </a:defRPr>
             </a:pPr>
             <a:r>
+              <a:rPr sz="7200" dirty="0">
+                <a:latin typeface="Bahnschrift SemiBold" panose="020B0502040204020203" pitchFamily="34" charset="0"/>
+              </a:rPr>
               <a:t>VERITAS</a:t>
             </a:r>
           </a:p>
@@ -4965,6 +4764,9 @@
               </a:defRPr>
             </a:pPr>
             <a:r>
+              <a:rPr sz="2400" dirty="0">
+                <a:latin typeface="Arial Narrow" panose="020B0606020202030204" pitchFamily="34" charset="0"/>
+              </a:rPr>
               <a:t>Verifiable Evidence &amp; Registry for Integrity of Trusted AI Systems</a:t>
             </a:r>
           </a:p>
@@ -4980,24 +4782,88 @@
               </a:defRPr>
             </a:pPr>
             <a:r>
+              <a:rPr dirty="0"/>
               <a:t>“The Core Guarantee: Mathematically prove that the AI model serving an inference request is the exact model that was audited.”</a:t>
             </a:r>
-          </a:p>
-          <a:p>
-            <a:pPr>
-              <a:defRPr sz="1100">
-                <a:solidFill>
-                  <a:srgbClr val="94A3B8"/>
-                </a:solidFill>
-              </a:defRPr>
-            </a:pPr>
-            <a:r>
-              <a:t>Presenting to: FinTech Industry Leaders &amp; College Innovation Department</a:t>
-            </a:r>
-            <a:br/>
-            <a:r>
-              <a:t>Technical Foundation: RFC 6962 Merkle Log • Hardware TEE Attestation • Ed25519 • ZK-SNARKs</a:t>
-            </a:r>
+            <a:endParaRPr lang="en-US" dirty="0"/>
+          </a:p>
+          <a:p>
+            <a:pPr>
+              <a:spcAft>
+                <a:spcPts val="2000"/>
+              </a:spcAft>
+              <a:defRPr sz="1300" i="1">
+                <a:solidFill>
+                  <a:srgbClr val="475569"/>
+                </a:solidFill>
+              </a:defRPr>
+            </a:pPr>
+            <a:endParaRPr lang="en-US" dirty="0"/>
+          </a:p>
+          <a:p>
+            <a:pPr>
+              <a:spcAft>
+                <a:spcPts val="2000"/>
+              </a:spcAft>
+              <a:defRPr sz="1300" i="1">
+                <a:solidFill>
+                  <a:srgbClr val="475569"/>
+                </a:solidFill>
+              </a:defRPr>
+            </a:pPr>
+            <a:r>
+              <a:rPr lang="en-US" sz="2000" b="1" dirty="0"/>
+              <a:t>Team:</a:t>
+            </a:r>
+          </a:p>
+          <a:p>
+            <a:pPr>
+              <a:spcAft>
+                <a:spcPts val="2000"/>
+              </a:spcAft>
+              <a:defRPr sz="1300" i="1">
+                <a:solidFill>
+                  <a:srgbClr val="475569"/>
+                </a:solidFill>
+              </a:defRPr>
+            </a:pPr>
+            <a:r>
+              <a:rPr lang="en-US" dirty="0"/>
+              <a:t>DEBARGHA CHAKRABORTY</a:t>
+            </a:r>
+          </a:p>
+          <a:p>
+            <a:pPr>
+              <a:spcAft>
+                <a:spcPts val="2000"/>
+              </a:spcAft>
+              <a:defRPr sz="1300" i="1">
+                <a:solidFill>
+                  <a:srgbClr val="475569"/>
+                </a:solidFill>
+              </a:defRPr>
+            </a:pPr>
+            <a:r>
+              <a:rPr lang="en-US" dirty="0"/>
+              <a:t>VANYA ARORA</a:t>
+            </a:r>
+          </a:p>
+          <a:p>
+            <a:pPr>
+              <a:spcAft>
+                <a:spcPts val="2000"/>
+              </a:spcAft>
+              <a:defRPr sz="1300" i="1">
+                <a:solidFill>
+                  <a:srgbClr val="475569"/>
+                </a:solidFill>
+              </a:defRPr>
+            </a:pPr>
+            <a:r>
+              <a:rPr lang="en-US" dirty="0"/>
+              <a:t>ARUSH ASAHA</a:t>
+            </a:r>
+            <a:endParaRPr dirty="0"/>
           </a:p>
         </p:txBody>
       </p:sp>
@@ -5010,7 +4876,7 @@
 </file>
 
 <file path=ppt/slides/slide10.xml><?xml version="1.0" encoding="utf-8"?>
-<p:sld xmlns:a="http://schemas.openxmlformats.org/drawingml/2006/main" xmlns:p="http://schemas.openxmlformats.org/presentationml/2006/main" xmlns:r="http://schemas.openxmlformats.org/officeDocument/2006/relationships">
+<p:sld xmlns:a="http://schemas.openxmlformats.org/drawingml/2006/main" xmlns:r="http://schemas.openxmlformats.org/officeDocument/2006/relationships" xmlns:p="http://schemas.openxmlformats.org/presentationml/2006/main">
   <p:cSld>
     <p:spTree>
       <p:nvGrpSpPr>
@@ -5018,7 +4884,14 @@
         <p:cNvGrpSpPr/>
         <p:nvPr/>
       </p:nvGrpSpPr>
-      <p:grpSpPr/>
+      <p:grpSpPr>
+        <a:xfrm>
+          <a:off x="0" y="0"/>
+          <a:ext cx="0" cy="0"/>
+          <a:chOff x="0" y="0"/>
+          <a:chExt cx="0" cy="0"/>
+        </a:xfrm>
+      </p:grpSpPr>
       <p:sp>
         <p:nvSpPr>
           <p:cNvPr id="2" name="Rectangle 1"/>
@@ -5059,6 +4932,7 @@
           <a:lstStyle/>
           <a:p>
             <a:pPr algn="ctr"/>
+            <a:endParaRPr/>
           </a:p>
         </p:txBody>
       </p:sp>
@@ -5244,6 +5118,7 @@
           <a:lstStyle/>
           <a:p>
             <a:pPr algn="ctr"/>
+            <a:endParaRPr/>
           </a:p>
         </p:txBody>
       </p:sp>
@@ -5459,6 +5334,7 @@
           <a:lstStyle/>
           <a:p>
             <a:pPr algn="ctr"/>
+            <a:endParaRPr/>
           </a:p>
         </p:txBody>
       </p:sp>
@@ -5686,7 +5562,7 @@
 </file>
 
 <file path=ppt/slides/slide11.xml><?xml version="1.0" encoding="utf-8"?>
-<p:sld xmlns:a="http://schemas.openxmlformats.org/drawingml/2006/main" xmlns:p="http://schemas.openxmlformats.org/presentationml/2006/main" xmlns:r="http://schemas.openxmlformats.org/officeDocument/2006/relationships">
+<p:sld xmlns:a="http://schemas.openxmlformats.org/drawingml/2006/main" xmlns:r="http://schemas.openxmlformats.org/officeDocument/2006/relationships" xmlns:p="http://schemas.openxmlformats.org/presentationml/2006/main">
   <p:cSld>
     <p:spTree>
       <p:nvGrpSpPr>
@@ -5694,7 +5570,14 @@
         <p:cNvGrpSpPr/>
         <p:nvPr/>
       </p:nvGrpSpPr>
-      <p:grpSpPr/>
+      <p:grpSpPr>
+        <a:xfrm>
+          <a:off x="0" y="0"/>
+          <a:ext cx="0" cy="0"/>
+          <a:chOff x="0" y="0"/>
+          <a:chExt cx="0" cy="0"/>
+        </a:xfrm>
+      </p:grpSpPr>
       <p:sp>
         <p:nvSpPr>
           <p:cNvPr id="2" name="Rectangle 1"/>
@@ -5735,6 +5618,7 @@
           <a:lstStyle/>
           <a:p>
             <a:pPr algn="ctr"/>
+            <a:endParaRPr/>
           </a:p>
         </p:txBody>
       </p:sp>
@@ -5897,10 +5781,34 @@
                 <a:tableStyleId>{5C22544A-7EE6-4342-B048-85BDC9FD1C3A}</a:tableStyleId>
               </a:tblPr>
               <a:tblGrid>
-                <a:gridCol w="1097280"/>
-                <a:gridCol w="3291840"/>
-                <a:gridCol w="2011680"/>
-                <a:gridCol w="4297680"/>
+                <a:gridCol w="1097280">
+                  <a:extLst>
+                    <a:ext uri="{9D8B030D-6E8A-4147-A177-3AD203B41FA5}">
+                      <a16:colId xmlns:a16="http://schemas.microsoft.com/office/drawing/2014/main" val="20000"/>
+                    </a:ext>
+                  </a:extLst>
+                </a:gridCol>
+                <a:gridCol w="3291840">
+                  <a:extLst>
+                    <a:ext uri="{9D8B030D-6E8A-4147-A177-3AD203B41FA5}">
+                      <a16:colId xmlns:a16="http://schemas.microsoft.com/office/drawing/2014/main" val="20001"/>
+                    </a:ext>
+                  </a:extLst>
+                </a:gridCol>
+                <a:gridCol w="2011680">
+                  <a:extLst>
+                    <a:ext uri="{9D8B030D-6E8A-4147-A177-3AD203B41FA5}">
+                      <a16:colId xmlns:a16="http://schemas.microsoft.com/office/drawing/2014/main" val="20002"/>
+                    </a:ext>
+                  </a:extLst>
+                </a:gridCol>
+                <a:gridCol w="4297680">
+                  <a:extLst>
+                    <a:ext uri="{9D8B030D-6E8A-4147-A177-3AD203B41FA5}">
+                      <a16:colId xmlns:a16="http://schemas.microsoft.com/office/drawing/2014/main" val="20003"/>
+                    </a:ext>
+                  </a:extLst>
+                </a:gridCol>
               </a:tblGrid>
               <a:tr h="627017">
                 <a:tc>
@@ -5995,6 +5903,11 @@
                     </a:solidFill>
                   </a:tcPr>
                 </a:tc>
+                <a:extLst>
+                  <a:ext uri="{0D108BD9-81ED-4DB2-BD59-A6C34878D82A}">
+                    <a16:rowId xmlns:a16="http://schemas.microsoft.com/office/drawing/2014/main" val="10000"/>
+                  </a:ext>
+                </a:extLst>
               </a:tr>
               <a:tr h="627017">
                 <a:tc>
@@ -6089,6 +6002,11 @@
                     </a:solidFill>
                   </a:tcPr>
                 </a:tc>
+                <a:extLst>
+                  <a:ext uri="{0D108BD9-81ED-4DB2-BD59-A6C34878D82A}">
+                    <a16:rowId xmlns:a16="http://schemas.microsoft.com/office/drawing/2014/main" val="10001"/>
+                  </a:ext>
+                </a:extLst>
               </a:tr>
               <a:tr h="627017">
                 <a:tc>
@@ -6183,6 +6101,11 @@
                     </a:solidFill>
                   </a:tcPr>
                 </a:tc>
+                <a:extLst>
+                  <a:ext uri="{0D108BD9-81ED-4DB2-BD59-A6C34878D82A}">
+                    <a16:rowId xmlns:a16="http://schemas.microsoft.com/office/drawing/2014/main" val="10002"/>
+                  </a:ext>
+                </a:extLst>
               </a:tr>
               <a:tr h="627017">
                 <a:tc>
@@ -6277,6 +6200,11 @@
                     </a:solidFill>
                   </a:tcPr>
                 </a:tc>
+                <a:extLst>
+                  <a:ext uri="{0D108BD9-81ED-4DB2-BD59-A6C34878D82A}">
+                    <a16:rowId xmlns:a16="http://schemas.microsoft.com/office/drawing/2014/main" val="10003"/>
+                  </a:ext>
+                </a:extLst>
               </a:tr>
               <a:tr h="627017">
                 <a:tc>
@@ -6371,6 +6299,11 @@
                     </a:solidFill>
                   </a:tcPr>
                 </a:tc>
+                <a:extLst>
+                  <a:ext uri="{0D108BD9-81ED-4DB2-BD59-A6C34878D82A}">
+                    <a16:rowId xmlns:a16="http://schemas.microsoft.com/office/drawing/2014/main" val="10004"/>
+                  </a:ext>
+                </a:extLst>
               </a:tr>
               <a:tr h="627017">
                 <a:tc>
@@ -6465,6 +6398,11 @@
                     </a:solidFill>
                   </a:tcPr>
                 </a:tc>
+                <a:extLst>
+                  <a:ext uri="{0D108BD9-81ED-4DB2-BD59-A6C34878D82A}">
+                    <a16:rowId xmlns:a16="http://schemas.microsoft.com/office/drawing/2014/main" val="10005"/>
+                  </a:ext>
+                </a:extLst>
               </a:tr>
               <a:tr h="627018">
                 <a:tc>
@@ -6559,6 +6497,11 @@
                     </a:solidFill>
                   </a:tcPr>
                 </a:tc>
+                <a:extLst>
+                  <a:ext uri="{0D108BD9-81ED-4DB2-BD59-A6C34878D82A}">
+                    <a16:rowId xmlns:a16="http://schemas.microsoft.com/office/drawing/2014/main" val="10006"/>
+                  </a:ext>
+                </a:extLst>
               </a:tr>
             </a:tbl>
           </a:graphicData>
@@ -6573,7 +6516,7 @@
 </file>
 
 <file path=ppt/slides/slide12.xml><?xml version="1.0" encoding="utf-8"?>
-<p:sld xmlns:a="http://schemas.openxmlformats.org/drawingml/2006/main" xmlns:p="http://schemas.openxmlformats.org/presentationml/2006/main" xmlns:r="http://schemas.openxmlformats.org/officeDocument/2006/relationships">
+<p:sld xmlns:a="http://schemas.openxmlformats.org/drawingml/2006/main" xmlns:r="http://schemas.openxmlformats.org/officeDocument/2006/relationships" xmlns:p="http://schemas.openxmlformats.org/presentationml/2006/main">
   <p:cSld>
     <p:spTree>
       <p:nvGrpSpPr>
@@ -6581,7 +6524,14 @@
         <p:cNvGrpSpPr/>
         <p:nvPr/>
       </p:nvGrpSpPr>
-      <p:grpSpPr/>
+      <p:grpSpPr>
+        <a:xfrm>
+          <a:off x="0" y="0"/>
+          <a:ext cx="0" cy="0"/>
+          <a:chOff x="0" y="0"/>
+          <a:chExt cx="0" cy="0"/>
+        </a:xfrm>
+      </p:grpSpPr>
       <p:sp>
         <p:nvSpPr>
           <p:cNvPr id="2" name="Rectangle 1"/>
@@ -6622,6 +6572,7 @@
           <a:lstStyle/>
           <a:p>
             <a:pPr algn="ctr"/>
+            <a:endParaRPr/>
           </a:p>
         </p:txBody>
       </p:sp>
@@ -6807,6 +6758,7 @@
           <a:lstStyle/>
           <a:p>
             <a:pPr algn="ctr"/>
+            <a:endParaRPr/>
           </a:p>
         </p:txBody>
       </p:sp>
@@ -6914,6 +6866,7 @@
           <a:lstStyle/>
           <a:p>
             <a:pPr algn="ctr"/>
+            <a:endParaRPr/>
           </a:p>
         </p:txBody>
       </p:sp>
@@ -7021,6 +6974,7 @@
           <a:lstStyle/>
           <a:p>
             <a:pPr algn="ctr"/>
+            <a:endParaRPr/>
           </a:p>
         </p:txBody>
       </p:sp>
@@ -7128,6 +7082,7 @@
           <a:lstStyle/>
           <a:p>
             <a:pPr algn="ctr"/>
+            <a:endParaRPr/>
           </a:p>
         </p:txBody>
       </p:sp>
@@ -7235,6 +7190,7 @@
           <a:lstStyle/>
           <a:p>
             <a:pPr algn="ctr"/>
+            <a:endParaRPr/>
           </a:p>
         </p:txBody>
       </p:sp>
@@ -7342,6 +7298,7 @@
           <a:lstStyle/>
           <a:p>
             <a:pPr algn="ctr"/>
+            <a:endParaRPr/>
           </a:p>
         </p:txBody>
       </p:sp>
@@ -7416,7 +7373,7 @@
 </file>
 
 <file path=ppt/slides/slide13.xml><?xml version="1.0" encoding="utf-8"?>
-<p:sld xmlns:a="http://schemas.openxmlformats.org/drawingml/2006/main" xmlns:p="http://schemas.openxmlformats.org/presentationml/2006/main" xmlns:r="http://schemas.openxmlformats.org/officeDocument/2006/relationships">
+<p:sld xmlns:a="http://schemas.openxmlformats.org/drawingml/2006/main" xmlns:r="http://schemas.openxmlformats.org/officeDocument/2006/relationships" xmlns:p="http://schemas.openxmlformats.org/presentationml/2006/main">
   <p:cSld>
     <p:spTree>
       <p:nvGrpSpPr>
@@ -7424,7 +7381,14 @@
         <p:cNvGrpSpPr/>
         <p:nvPr/>
       </p:nvGrpSpPr>
-      <p:grpSpPr/>
+      <p:grpSpPr>
+        <a:xfrm>
+          <a:off x="0" y="0"/>
+          <a:ext cx="0" cy="0"/>
+          <a:chOff x="0" y="0"/>
+          <a:chExt cx="0" cy="0"/>
+        </a:xfrm>
+      </p:grpSpPr>
       <p:sp>
         <p:nvSpPr>
           <p:cNvPr id="2" name="Rectangle 1"/>
@@ -7465,6 +7429,7 @@
           <a:lstStyle/>
           <a:p>
             <a:pPr algn="ctr"/>
+            <a:endParaRPr/>
           </a:p>
         </p:txBody>
       </p:sp>
@@ -7650,6 +7615,7 @@
           <a:lstStyle/>
           <a:p>
             <a:pPr algn="ctr"/>
+            <a:endParaRPr/>
           </a:p>
         </p:txBody>
       </p:sp>
@@ -7880,6 +7846,7 @@
           <a:lstStyle/>
           <a:p>
             <a:pPr algn="ctr"/>
+            <a:endParaRPr/>
           </a:p>
         </p:txBody>
       </p:sp>
@@ -8122,7 +8089,7 @@
 </file>
 
 <file path=ppt/slides/slide14.xml><?xml version="1.0" encoding="utf-8"?>
-<p:sld xmlns:a="http://schemas.openxmlformats.org/drawingml/2006/main" xmlns:p="http://schemas.openxmlformats.org/presentationml/2006/main" xmlns:r="http://schemas.openxmlformats.org/officeDocument/2006/relationships">
+<p:sld xmlns:a="http://schemas.openxmlformats.org/drawingml/2006/main" xmlns:r="http://schemas.openxmlformats.org/officeDocument/2006/relationships" xmlns:p="http://schemas.openxmlformats.org/presentationml/2006/main">
   <p:cSld>
     <p:spTree>
       <p:nvGrpSpPr>
@@ -8130,7 +8097,14 @@
         <p:cNvGrpSpPr/>
         <p:nvPr/>
       </p:nvGrpSpPr>
-      <p:grpSpPr/>
+      <p:grpSpPr>
+        <a:xfrm>
+          <a:off x="0" y="0"/>
+          <a:ext cx="0" cy="0"/>
+          <a:chOff x="0" y="0"/>
+          <a:chExt cx="0" cy="0"/>
+        </a:xfrm>
+      </p:grpSpPr>
       <p:sp>
         <p:nvSpPr>
           <p:cNvPr id="2" name="Rectangle 1"/>
@@ -8171,6 +8145,7 @@
           <a:lstStyle/>
           <a:p>
             <a:pPr algn="ctr"/>
+            <a:endParaRPr/>
           </a:p>
         </p:txBody>
       </p:sp>
@@ -8356,6 +8331,7 @@
           <a:lstStyle/>
           <a:p>
             <a:pPr algn="ctr"/>
+            <a:endParaRPr/>
           </a:p>
         </p:txBody>
       </p:sp>
@@ -8496,6 +8472,7 @@
           <a:lstStyle/>
           <a:p>
             <a:pPr algn="ctr"/>
+            <a:endParaRPr/>
           </a:p>
         </p:txBody>
       </p:sp>
@@ -8636,6 +8613,7 @@
           <a:lstStyle/>
           <a:p>
             <a:pPr algn="ctr"/>
+            <a:endParaRPr/>
           </a:p>
         </p:txBody>
       </p:sp>
@@ -8776,6 +8754,7 @@
           <a:lstStyle/>
           <a:p>
             <a:pPr algn="ctr"/>
+            <a:endParaRPr/>
           </a:p>
         </p:txBody>
       </p:sp>
@@ -8868,7 +8847,7 @@
 </file>
 
 <file path=ppt/slides/slide15.xml><?xml version="1.0" encoding="utf-8"?>
-<p:sld xmlns:a="http://schemas.openxmlformats.org/drawingml/2006/main" xmlns:p="http://schemas.openxmlformats.org/presentationml/2006/main" xmlns:r="http://schemas.openxmlformats.org/officeDocument/2006/relationships">
+<p:sld xmlns:a="http://schemas.openxmlformats.org/drawingml/2006/main" xmlns:r="http://schemas.openxmlformats.org/officeDocument/2006/relationships" xmlns:p="http://schemas.openxmlformats.org/presentationml/2006/main">
   <p:cSld>
     <p:spTree>
       <p:nvGrpSpPr>
@@ -8876,7 +8855,14 @@
         <p:cNvGrpSpPr/>
         <p:nvPr/>
       </p:nvGrpSpPr>
-      <p:grpSpPr/>
+      <p:grpSpPr>
+        <a:xfrm>
+          <a:off x="0" y="0"/>
+          <a:ext cx="0" cy="0"/>
+          <a:chOff x="0" y="0"/>
+          <a:chExt cx="0" cy="0"/>
+        </a:xfrm>
+      </p:grpSpPr>
       <p:sp>
         <p:nvSpPr>
           <p:cNvPr id="2" name="Rectangle 1"/>
@@ -8917,6 +8903,7 @@
           <a:lstStyle/>
           <a:p>
             <a:pPr algn="ctr"/>
+            <a:endParaRPr/>
           </a:p>
         </p:txBody>
       </p:sp>
@@ -8962,6 +8949,7 @@
           <a:lstStyle/>
           <a:p>
             <a:pPr algn="ctr"/>
+            <a:endParaRPr/>
           </a:p>
         </p:txBody>
       </p:sp>
@@ -9085,7 +9073,7 @@
 </file>
 
 <file path=ppt/slides/slide2.xml><?xml version="1.0" encoding="utf-8"?>
-<p:sld xmlns:a="http://schemas.openxmlformats.org/drawingml/2006/main" xmlns:p="http://schemas.openxmlformats.org/presentationml/2006/main" xmlns:r="http://schemas.openxmlformats.org/officeDocument/2006/relationships">
+<p:sld xmlns:a="http://schemas.openxmlformats.org/drawingml/2006/main" xmlns:r="http://schemas.openxmlformats.org/officeDocument/2006/relationships" xmlns:p="http://schemas.openxmlformats.org/presentationml/2006/main">
   <p:cSld>
     <p:spTree>
       <p:nvGrpSpPr>
@@ -9093,7 +9081,14 @@
         <p:cNvGrpSpPr/>
         <p:nvPr/>
       </p:nvGrpSpPr>
-      <p:grpSpPr/>
+      <p:grpSpPr>
+        <a:xfrm>
+          <a:off x="0" y="0"/>
+          <a:ext cx="0" cy="0"/>
+          <a:chOff x="0" y="0"/>
+          <a:chExt cx="0" cy="0"/>
+        </a:xfrm>
+      </p:grpSpPr>
       <p:sp>
         <p:nvSpPr>
           <p:cNvPr id="2" name="Rectangle 1"/>
@@ -9134,6 +9129,7 @@
           <a:lstStyle/>
           <a:p>
             <a:pPr algn="ctr"/>
+            <a:endParaRPr/>
           </a:p>
         </p:txBody>
       </p:sp>
@@ -9319,6 +9315,7 @@
           <a:lstStyle/>
           <a:p>
             <a:pPr algn="ctr"/>
+            <a:endParaRPr/>
           </a:p>
         </p:txBody>
       </p:sp>
@@ -9474,6 +9471,7 @@
           <a:lstStyle/>
           <a:p>
             <a:pPr algn="ctr"/>
+            <a:endParaRPr/>
           </a:p>
         </p:txBody>
       </p:sp>
@@ -9614,6 +9612,7 @@
           <a:lstStyle/>
           <a:p>
             <a:pPr algn="ctr"/>
+            <a:endParaRPr/>
           </a:p>
         </p:txBody>
       </p:sp>
@@ -9721,7 +9720,7 @@
 </file>
 
 <file path=ppt/slides/slide3.xml><?xml version="1.0" encoding="utf-8"?>
-<p:sld xmlns:a="http://schemas.openxmlformats.org/drawingml/2006/main" xmlns:p="http://schemas.openxmlformats.org/presentationml/2006/main" xmlns:r="http://schemas.openxmlformats.org/officeDocument/2006/relationships">
+<p:sld xmlns:a="http://schemas.openxmlformats.org/drawingml/2006/main" xmlns:r="http://schemas.openxmlformats.org/officeDocument/2006/relationships" xmlns:p="http://schemas.openxmlformats.org/presentationml/2006/main">
   <p:cSld>
     <p:spTree>
       <p:nvGrpSpPr>
@@ -9729,7 +9728,14 @@
         <p:cNvGrpSpPr/>
         <p:nvPr/>
       </p:nvGrpSpPr>
-      <p:grpSpPr/>
+      <p:grpSpPr>
+        <a:xfrm>
+          <a:off x="0" y="0"/>
+          <a:ext cx="0" cy="0"/>
+          <a:chOff x="0" y="0"/>
+          <a:chExt cx="0" cy="0"/>
+        </a:xfrm>
+      </p:grpSpPr>
       <p:sp>
         <p:nvSpPr>
           <p:cNvPr id="2" name="Rectangle 1"/>
@@ -9770,6 +9776,7 @@
           <a:lstStyle/>
           <a:p>
             <a:pPr algn="ctr"/>
+            <a:endParaRPr/>
           </a:p>
         </p:txBody>
       </p:sp>
@@ -9955,6 +9962,7 @@
           <a:lstStyle/>
           <a:p>
             <a:pPr algn="ctr"/>
+            <a:endParaRPr/>
           </a:p>
         </p:txBody>
       </p:sp>
@@ -10095,6 +10103,7 @@
           <a:lstStyle/>
           <a:p>
             <a:pPr algn="ctr"/>
+            <a:endParaRPr/>
           </a:p>
         </p:txBody>
       </p:sp>
@@ -10235,6 +10244,7 @@
           <a:lstStyle/>
           <a:p>
             <a:pPr algn="ctr"/>
+            <a:endParaRPr/>
           </a:p>
         </p:txBody>
       </p:sp>
@@ -10375,6 +10385,7 @@
           <a:lstStyle/>
           <a:p>
             <a:pPr algn="ctr"/>
+            <a:endParaRPr/>
           </a:p>
         </p:txBody>
       </p:sp>
@@ -10482,7 +10493,7 @@
 </file>
 
 <file path=ppt/slides/slide4.xml><?xml version="1.0" encoding="utf-8"?>
-<p:sld xmlns:a="http://schemas.openxmlformats.org/drawingml/2006/main" xmlns:p="http://schemas.openxmlformats.org/presentationml/2006/main" xmlns:r="http://schemas.openxmlformats.org/officeDocument/2006/relationships">
+<p:sld xmlns:a="http://schemas.openxmlformats.org/drawingml/2006/main" xmlns:r="http://schemas.openxmlformats.org/officeDocument/2006/relationships" xmlns:p="http://schemas.openxmlformats.org/presentationml/2006/main">
   <p:cSld>
     <p:spTree>
       <p:nvGrpSpPr>
@@ -10490,7 +10501,14 @@
         <p:cNvGrpSpPr/>
         <p:nvPr/>
       </p:nvGrpSpPr>
-      <p:grpSpPr/>
+      <p:grpSpPr>
+        <a:xfrm>
+          <a:off x="0" y="0"/>
+          <a:ext cx="0" cy="0"/>
+          <a:chOff x="0" y="0"/>
+          <a:chExt cx="0" cy="0"/>
+        </a:xfrm>
+      </p:grpSpPr>
       <p:sp>
         <p:nvSpPr>
           <p:cNvPr id="2" name="Rectangle 1"/>
@@ -10531,6 +10549,7 @@
           <a:lstStyle/>
           <a:p>
             <a:pPr algn="ctr"/>
+            <a:endParaRPr/>
           </a:p>
         </p:txBody>
       </p:sp>
@@ -10716,6 +10735,7 @@
           <a:lstStyle/>
           <a:p>
             <a:pPr algn="ctr"/>
+            <a:endParaRPr/>
           </a:p>
         </p:txBody>
       </p:sp>
@@ -10916,6 +10936,7 @@
           <a:lstStyle/>
           <a:p>
             <a:pPr algn="ctr"/>
+            <a:endParaRPr/>
           </a:p>
         </p:txBody>
       </p:sp>
@@ -11128,7 +11149,7 @@
 </file>
 
 <file path=ppt/slides/slide5.xml><?xml version="1.0" encoding="utf-8"?>
-<p:sld xmlns:a="http://schemas.openxmlformats.org/drawingml/2006/main" xmlns:p="http://schemas.openxmlformats.org/presentationml/2006/main" xmlns:r="http://schemas.openxmlformats.org/officeDocument/2006/relationships">
+<p:sld xmlns:a="http://schemas.openxmlformats.org/drawingml/2006/main" xmlns:r="http://schemas.openxmlformats.org/officeDocument/2006/relationships" xmlns:p="http://schemas.openxmlformats.org/presentationml/2006/main">
   <p:cSld>
     <p:spTree>
       <p:nvGrpSpPr>
@@ -11136,7 +11157,14 @@
         <p:cNvGrpSpPr/>
         <p:nvPr/>
       </p:nvGrpSpPr>
-      <p:grpSpPr/>
+      <p:grpSpPr>
+        <a:xfrm>
+          <a:off x="0" y="0"/>
+          <a:ext cx="0" cy="0"/>
+          <a:chOff x="0" y="0"/>
+          <a:chExt cx="0" cy="0"/>
+        </a:xfrm>
+      </p:grpSpPr>
       <p:sp>
         <p:nvSpPr>
           <p:cNvPr id="2" name="Rectangle 1"/>
@@ -11177,6 +11205,7 @@
           <a:lstStyle/>
           <a:p>
             <a:pPr algn="ctr"/>
+            <a:endParaRPr/>
           </a:p>
         </p:txBody>
       </p:sp>
@@ -11362,6 +11391,7 @@
           <a:lstStyle/>
           <a:p>
             <a:pPr algn="ctr"/>
+            <a:endParaRPr/>
           </a:p>
         </p:txBody>
       </p:sp>
@@ -11502,6 +11532,7 @@
           <a:lstStyle/>
           <a:p>
             <a:pPr algn="ctr"/>
+            <a:endParaRPr/>
           </a:p>
         </p:txBody>
       </p:sp>
@@ -11642,6 +11673,7 @@
           <a:lstStyle/>
           <a:p>
             <a:pPr algn="ctr"/>
+            <a:endParaRPr/>
           </a:p>
         </p:txBody>
       </p:sp>
@@ -11782,6 +11814,7 @@
           <a:lstStyle/>
           <a:p>
             <a:pPr algn="ctr"/>
+            <a:endParaRPr/>
           </a:p>
         </p:txBody>
       </p:sp>
@@ -11922,6 +11955,7 @@
           <a:lstStyle/>
           <a:p>
             <a:pPr algn="ctr"/>
+            <a:endParaRPr/>
           </a:p>
         </p:txBody>
       </p:sp>
@@ -12029,7 +12063,7 @@
 </file>
 
 <file path=ppt/slides/slide6.xml><?xml version="1.0" encoding="utf-8"?>
-<p:sld xmlns:a="http://schemas.openxmlformats.org/drawingml/2006/main" xmlns:p="http://schemas.openxmlformats.org/presentationml/2006/main" xmlns:r="http://schemas.openxmlformats.org/officeDocument/2006/relationships">
+<p:sld xmlns:a="http://schemas.openxmlformats.org/drawingml/2006/main" xmlns:r="http://schemas.openxmlformats.org/officeDocument/2006/relationships" xmlns:p="http://schemas.openxmlformats.org/presentationml/2006/main">
   <p:cSld>
     <p:spTree>
       <p:nvGrpSpPr>
@@ -12037,7 +12071,14 @@
         <p:cNvGrpSpPr/>
         <p:nvPr/>
       </p:nvGrpSpPr>
-      <p:grpSpPr/>
+      <p:grpSpPr>
+        <a:xfrm>
+          <a:off x="0" y="0"/>
+          <a:ext cx="0" cy="0"/>
+          <a:chOff x="0" y="0"/>
+          <a:chExt cx="0" cy="0"/>
+        </a:xfrm>
+      </p:grpSpPr>
       <p:sp>
         <p:nvSpPr>
           <p:cNvPr id="2" name="Rectangle 1"/>
@@ -12078,6 +12119,7 @@
           <a:lstStyle/>
           <a:p>
             <a:pPr algn="ctr"/>
+            <a:endParaRPr/>
           </a:p>
         </p:txBody>
       </p:sp>
@@ -12263,6 +12305,7 @@
           <a:lstStyle/>
           <a:p>
             <a:pPr algn="ctr"/>
+            <a:endParaRPr/>
           </a:p>
         </p:txBody>
       </p:sp>
@@ -12355,6 +12398,7 @@
           <a:lstStyle/>
           <a:p>
             <a:pPr algn="ctr"/>
+            <a:endParaRPr/>
           </a:p>
         </p:txBody>
       </p:sp>
@@ -12447,6 +12491,7 @@
           <a:lstStyle/>
           <a:p>
             <a:pPr algn="ctr"/>
+            <a:endParaRPr/>
           </a:p>
         </p:txBody>
       </p:sp>
@@ -12539,6 +12584,7 @@
           <a:lstStyle/>
           <a:p>
             <a:pPr algn="ctr"/>
+            <a:endParaRPr/>
           </a:p>
         </p:txBody>
       </p:sp>
@@ -12631,6 +12677,7 @@
           <a:lstStyle/>
           <a:p>
             <a:pPr algn="ctr"/>
+            <a:endParaRPr/>
           </a:p>
         </p:txBody>
       </p:sp>
@@ -12690,7 +12737,7 @@
 </file>
 
 <file path=ppt/slides/slide7.xml><?xml version="1.0" encoding="utf-8"?>
-<p:sld xmlns:a="http://schemas.openxmlformats.org/drawingml/2006/main" xmlns:p="http://schemas.openxmlformats.org/presentationml/2006/main" xmlns:r="http://schemas.openxmlformats.org/officeDocument/2006/relationships">
+<p:sld xmlns:a="http://schemas.openxmlformats.org/drawingml/2006/main" xmlns:r="http://schemas.openxmlformats.org/officeDocument/2006/relationships" xmlns:p="http://schemas.openxmlformats.org/presentationml/2006/main">
   <p:cSld>
     <p:spTree>
       <p:nvGrpSpPr>
@@ -12698,7 +12745,14 @@
         <p:cNvGrpSpPr/>
         <p:nvPr/>
       </p:nvGrpSpPr>
-      <p:grpSpPr/>
+      <p:grpSpPr>
+        <a:xfrm>
+          <a:off x="0" y="0"/>
+          <a:ext cx="0" cy="0"/>
+          <a:chOff x="0" y="0"/>
+          <a:chExt cx="0" cy="0"/>
+        </a:xfrm>
+      </p:grpSpPr>
       <p:sp>
         <p:nvSpPr>
           <p:cNvPr id="2" name="Rectangle 1"/>
@@ -12739,6 +12793,7 @@
           <a:lstStyle/>
           <a:p>
             <a:pPr algn="ctr"/>
+            <a:endParaRPr/>
           </a:p>
         </p:txBody>
       </p:sp>
@@ -12924,6 +12979,7 @@
           <a:lstStyle/>
           <a:p>
             <a:pPr algn="ctr"/>
+            <a:endParaRPr/>
           </a:p>
         </p:txBody>
       </p:sp>
@@ -13154,6 +13210,7 @@
           <a:lstStyle/>
           <a:p>
             <a:pPr algn="ctr"/>
+            <a:endParaRPr/>
           </a:p>
         </p:txBody>
       </p:sp>
@@ -13366,7 +13423,7 @@
 </file>
 
 <file path=ppt/slides/slide8.xml><?xml version="1.0" encoding="utf-8"?>
-<p:sld xmlns:a="http://schemas.openxmlformats.org/drawingml/2006/main" xmlns:p="http://schemas.openxmlformats.org/presentationml/2006/main" xmlns:r="http://schemas.openxmlformats.org/officeDocument/2006/relationships">
+<p:sld xmlns:a="http://schemas.openxmlformats.org/drawingml/2006/main" xmlns:r="http://schemas.openxmlformats.org/officeDocument/2006/relationships" xmlns:p="http://schemas.openxmlformats.org/presentationml/2006/main">
   <p:cSld>
     <p:spTree>
       <p:nvGrpSpPr>
@@ -13374,7 +13431,14 @@
         <p:cNvGrpSpPr/>
         <p:nvPr/>
       </p:nvGrpSpPr>
-      <p:grpSpPr/>
+      <p:grpSpPr>
+        <a:xfrm>
+          <a:off x="0" y="0"/>
+          <a:ext cx="0" cy="0"/>
+          <a:chOff x="0" y="0"/>
+          <a:chExt cx="0" cy="0"/>
+        </a:xfrm>
+      </p:grpSpPr>
       <p:sp>
         <p:nvSpPr>
           <p:cNvPr id="2" name="Rectangle 1"/>
@@ -13415,6 +13479,7 @@
           <a:lstStyle/>
           <a:p>
             <a:pPr algn="ctr"/>
+            <a:endParaRPr/>
           </a:p>
         </p:txBody>
       </p:sp>
@@ -13600,6 +13665,7 @@
           <a:lstStyle/>
           <a:p>
             <a:pPr algn="ctr"/>
+            <a:endParaRPr/>
           </a:p>
         </p:txBody>
       </p:sp>
@@ -13845,6 +13911,7 @@
           <a:lstStyle/>
           <a:p>
             <a:pPr algn="ctr"/>
+            <a:endParaRPr/>
           </a:p>
         </p:txBody>
       </p:sp>
@@ -14027,7 +14094,7 @@
 </file>
 
 <file path=ppt/slides/slide9.xml><?xml version="1.0" encoding="utf-8"?>
-<p:sld xmlns:a="http://schemas.openxmlformats.org/drawingml/2006/main" xmlns:p="http://schemas.openxmlformats.org/presentationml/2006/main" xmlns:r="http://schemas.openxmlformats.org/officeDocument/2006/relationships">
+<p:sld xmlns:a="http://schemas.openxmlformats.org/drawingml/2006/main" xmlns:r="http://schemas.openxmlformats.org/officeDocument/2006/relationships" xmlns:p="http://schemas.openxmlformats.org/presentationml/2006/main">
   <p:cSld>
     <p:spTree>
       <p:nvGrpSpPr>
@@ -14035,7 +14102,14 @@
         <p:cNvGrpSpPr/>
         <p:nvPr/>
       </p:nvGrpSpPr>
-      <p:grpSpPr/>
+      <p:grpSpPr>
+        <a:xfrm>
+          <a:off x="0" y="0"/>
+          <a:ext cx="0" cy="0"/>
+          <a:chOff x="0" y="0"/>
+          <a:chExt cx="0" cy="0"/>
+        </a:xfrm>
+      </p:grpSpPr>
       <p:sp>
         <p:nvSpPr>
           <p:cNvPr id="2" name="Rectangle 1"/>
@@ -14076,6 +14150,7 @@
           <a:lstStyle/>
           <a:p>
             <a:pPr algn="ctr"/>
+            <a:endParaRPr/>
           </a:p>
         </p:txBody>
       </p:sp>
@@ -14261,6 +14336,7 @@
           <a:lstStyle/>
           <a:p>
             <a:pPr algn="ctr"/>
+            <a:endParaRPr/>
           </a:p>
         </p:txBody>
       </p:sp>
@@ -14506,6 +14582,7 @@
           <a:lstStyle/>
           <a:p>
             <a:pPr algn="ctr"/>
+            <a:endParaRPr/>
           </a:p>
         </p:txBody>
       </p:sp>
@@ -15018,44 +15095,44 @@
         <a:sysClr val="window" lastClr="FFFFFF"/>
       </a:lt1>
       <a:dk2>
-        <a:srgbClr val="1F497D"/>
+        <a:srgbClr val="0E2841"/>
       </a:dk2>
       <a:lt2>
-        <a:srgbClr val="EEECE1"/>
+        <a:srgbClr val="E8E8E8"/>
       </a:lt2>
       <a:accent1>
-        <a:srgbClr val="4F81BD"/>
+        <a:srgbClr val="156082"/>
       </a:accent1>
       <a:accent2>
-        <a:srgbClr val="C0504D"/>
+        <a:srgbClr val="E97132"/>
       </a:accent2>
       <a:accent3>
-        <a:srgbClr val="9BBB59"/>
+        <a:srgbClr val="196B24"/>
       </a:accent3>
       <a:accent4>
-        <a:srgbClr val="8064A2"/>
+        <a:srgbClr val="0F9ED5"/>
       </a:accent4>
       <a:accent5>
-        <a:srgbClr val="4BACC6"/>
+        <a:srgbClr val="A02B93"/>
       </a:accent5>
       <a:accent6>
-        <a:srgbClr val="F79646"/>
+        <a:srgbClr val="4EA72E"/>
       </a:accent6>
       <a:hlink>
-        <a:srgbClr val="0000FF"/>
+        <a:srgbClr val="467886"/>
       </a:hlink>
       <a:folHlink>
-        <a:srgbClr val="800080"/>
+        <a:srgbClr val="96607D"/>
       </a:folHlink>
     </a:clrScheme>
     <a:fontScheme name="Office">
       <a:majorFont>
-        <a:latin typeface="Calibri"/>
+        <a:latin typeface="Aptos Display" panose="02110004020202020204"/>
         <a:ea typeface=""/>
         <a:cs typeface=""/>
-        <a:font script="Jpan" typeface="ＭＳ Ｐゴシック"/>
+        <a:font script="Jpan" typeface="游ゴシック Light"/>
         <a:font script="Hang" typeface="맑은 고딕"/>
-        <a:font script="Hans" typeface="宋体"/>
+        <a:font script="Hans" typeface="等线 Light"/>
         <a:font script="Hant" typeface="新細明體"/>
         <a:font script="Arab" typeface="Times New Roman"/>
         <a:font script="Hebr" typeface="Times New Roman"/>
@@ -15083,14 +15160,31 @@
         <a:font script="Viet" typeface="Times New Roman"/>
         <a:font script="Uigh" typeface="Microsoft Uighur"/>
         <a:font script="Geor" typeface="Sylfaen"/>
+        <a:font script="Armn" typeface="Arial"/>
+        <a:font script="Bugi" typeface="Leelawadee UI"/>
+        <a:font script="Bopo" typeface="Microsoft JhengHei"/>
+        <a:font script="Java" typeface="Javanese Text"/>
+        <a:font script="Lisu" typeface="Segoe UI"/>
+        <a:font script="Mymr" typeface="Myanmar Text"/>
+        <a:font script="Nkoo" typeface="Ebrima"/>
+        <a:font script="Olck" typeface="Nirmala UI"/>
+        <a:font script="Osma" typeface="Ebrima"/>
+        <a:font script="Phag" typeface="Phagspa"/>
+        <a:font script="Syrn" typeface="Estrangelo Edessa"/>
+        <a:font script="Syrj" typeface="Estrangelo Edessa"/>
+        <a:font script="Syre" typeface="Estrangelo Edessa"/>
+        <a:font script="Sora" typeface="Nirmala UI"/>
+        <a:font script="Tale" typeface="Microsoft Tai Le"/>
+        <a:font script="Talu" typeface="Microsoft New Tai Lue"/>
+        <a:font script="Tfng" typeface="Ebrima"/>
       </a:majorFont>
       <a:minorFont>
-        <a:latin typeface="Calibri"/>
+        <a:latin typeface="Aptos" panose="02110004020202020204"/>
         <a:ea typeface=""/>
         <a:cs typeface=""/>
-        <a:font script="Jpan" typeface="ＭＳ Ｐゴシック"/>
+        <a:font script="Jpan" typeface="游ゴシック"/>
         <a:font script="Hang" typeface="맑은 고딕"/>
-        <a:font script="Hans" typeface="宋体"/>
+        <a:font script="Hans" typeface="等线"/>
         <a:font script="Hant" typeface="新細明體"/>
         <a:font script="Arab" typeface="Arial"/>
         <a:font script="Hebr" typeface="Arial"/>
@@ -15118,6 +15212,23 @@
         <a:font script="Viet" typeface="Arial"/>
         <a:font script="Uigh" typeface="Microsoft Uighur"/>
         <a:font script="Geor" typeface="Sylfaen"/>
+        <a:font script="Armn" typeface="Arial"/>
+        <a:font script="Bugi" typeface="Leelawadee UI"/>
+        <a:font script="Bopo" typeface="Microsoft JhengHei"/>
+        <a:font script="Java" typeface="Javanese Text"/>
+        <a:font script="Lisu" typeface="Segoe UI"/>
+        <a:font script="Mymr" typeface="Myanmar Text"/>
+        <a:font script="Nkoo" typeface="Ebrima"/>
+        <a:font script="Olck" typeface="Nirmala UI"/>
+        <a:font script="Osma" typeface="Ebrima"/>
+        <a:font script="Phag" typeface="Phagspa"/>
+        <a:font script="Syrn" typeface="Estrangelo Edessa"/>
+        <a:font script="Syrj" typeface="Estrangelo Edessa"/>
+        <a:font script="Syre" typeface="Estrangelo Edessa"/>
+        <a:font script="Sora" typeface="Nirmala UI"/>
+        <a:font script="Tale" typeface="Microsoft Tai Le"/>
+        <a:font script="Talu" typeface="Microsoft New Tai Lue"/>
+        <a:font script="Tfng" typeface="Ebrima"/>
       </a:minorFont>
     </a:fontScheme>
     <a:fmtScheme name="Office">
@@ -15129,180 +15240,136 @@
           <a:gsLst>
             <a:gs pos="0">
               <a:schemeClr val="phClr">
-                <a:tint val="50000"/>
-                <a:satMod val="300000"/>
+                <a:lumMod val="110000"/>
+                <a:satMod val="105000"/>
+                <a:tint val="67000"/>
               </a:schemeClr>
             </a:gs>
-            <a:gs pos="35000">
+            <a:gs pos="50000">
               <a:schemeClr val="phClr">
-                <a:tint val="37000"/>
-                <a:satMod val="300000"/>
+                <a:lumMod val="105000"/>
+                <a:satMod val="103000"/>
+                <a:tint val="73000"/>
               </a:schemeClr>
             </a:gs>
             <a:gs pos="100000">
               <a:schemeClr val="phClr">
-                <a:tint val="15000"/>
-                <a:satMod val="350000"/>
+                <a:lumMod val="105000"/>
+                <a:satMod val="109000"/>
+                <a:tint val="81000"/>
               </a:schemeClr>
             </a:gs>
           </a:gsLst>
-          <a:lin ang="16200000" scaled="1"/>
+          <a:lin ang="5400000" scaled="0"/>
         </a:gradFill>
         <a:gradFill rotWithShape="1">
           <a:gsLst>
             <a:gs pos="0">
               <a:schemeClr val="phClr">
-                <a:tint val="100000"/>
+                <a:satMod val="103000"/>
+                <a:lumMod val="102000"/>
+                <a:tint val="94000"/>
+              </a:schemeClr>
+            </a:gs>
+            <a:gs pos="50000">
+              <a:schemeClr val="phClr">
+                <a:satMod val="110000"/>
+                <a:lumMod val="100000"/>
                 <a:shade val="100000"/>
-                <a:satMod val="130000"/>
               </a:schemeClr>
             </a:gs>
             <a:gs pos="100000">
               <a:schemeClr val="phClr">
-                <a:tint val="50000"/>
-                <a:shade val="100000"/>
-                <a:satMod val="350000"/>
+                <a:lumMod val="99000"/>
+                <a:satMod val="120000"/>
+                <a:shade val="78000"/>
               </a:schemeClr>
             </a:gs>
           </a:gsLst>
-          <a:lin ang="16200000" scaled="0"/>
+          <a:lin ang="5400000" scaled="0"/>
         </a:gradFill>
       </a:fillStyleLst>
       <a:lnStyleLst>
-        <a:ln w="9525" cap="flat" cmpd="sng" algn="ctr">
+        <a:ln w="12700" cap="flat" cmpd="sng" algn="ctr">
           <a:solidFill>
-            <a:schemeClr val="phClr">
-              <a:shade val="95000"/>
-              <a:satMod val="105000"/>
-            </a:schemeClr>
+            <a:schemeClr val="phClr"/>
           </a:solidFill>
           <a:prstDash val="solid"/>
+          <a:miter lim="800000"/>
+        </a:ln>
+        <a:ln w="19050" cap="flat" cmpd="sng" algn="ctr">
+          <a:solidFill>
+            <a:schemeClr val="phClr"/>
+          </a:solidFill>
+          <a:prstDash val="solid"/>
+          <a:miter lim="800000"/>
         </a:ln>
         <a:ln w="25400" cap="flat" cmpd="sng" algn="ctr">
           <a:solidFill>
             <a:schemeClr val="phClr"/>
           </a:solidFill>
           <a:prstDash val="solid"/>
-        </a:ln>
-        <a:ln w="38100" cap="flat" cmpd="sng" algn="ctr">
-          <a:solidFill>
-            <a:schemeClr val="phClr"/>
-          </a:solidFill>
-          <a:prstDash val="solid"/>
+          <a:miter lim="800000"/>
         </a:ln>
       </a:lnStyleLst>
       <a:effectStyleLst>
         <a:effectStyle>
+          <a:effectLst/>
+        </a:effectStyle>
+        <a:effectStyle>
+          <a:effectLst/>
+        </a:effectStyle>
+        <a:effectStyle>
           <a:effectLst>
-            <a:outerShdw blurRad="40000" dist="20000" dir="5400000" rotWithShape="0">
+            <a:outerShdw blurRad="57150" dist="19050" dir="5400000" algn="ctr" rotWithShape="0">
               <a:srgbClr val="000000">
-                <a:alpha val="38000"/>
+                <a:alpha val="63000"/>
               </a:srgbClr>
             </a:outerShdw>
           </a:effectLst>
-        </a:effectStyle>
-        <a:effectStyle>
-          <a:effectLst>
-            <a:outerShdw blurRad="40000" dist="23000" dir="5400000" rotWithShape="0">
-              <a:srgbClr val="000000">
-                <a:alpha val="35000"/>
-              </a:srgbClr>
-            </a:outerShdw>
-          </a:effectLst>
-        </a:effectStyle>
-        <a:effectStyle>
-          <a:effectLst>
-            <a:outerShdw blurRad="40000" dist="23000" dir="5400000" rotWithShape="0">
-              <a:srgbClr val="000000">
-                <a:alpha val="35000"/>
-              </a:srgbClr>
-            </a:outerShdw>
-          </a:effectLst>
-          <a:scene3d>
-            <a:camera prst="orthographicFront">
-              <a:rot lat="0" lon="0" rev="0"/>
-            </a:camera>
-            <a:lightRig rig="threePt" dir="t">
-              <a:rot lat="0" lon="0" rev="1200000"/>
-            </a:lightRig>
-          </a:scene3d>
-          <a:sp3d>
-            <a:bevelT w="63500" h="25400"/>
-          </a:sp3d>
         </a:effectStyle>
       </a:effectStyleLst>
       <a:bgFillStyleLst>
         <a:solidFill>
           <a:schemeClr val="phClr"/>
         </a:solidFill>
+        <a:solidFill>
+          <a:schemeClr val="phClr">
+            <a:tint val="95000"/>
+            <a:satMod val="170000"/>
+          </a:schemeClr>
+        </a:solidFill>
         <a:gradFill rotWithShape="1">
           <a:gsLst>
             <a:gs pos="0">
               <a:schemeClr val="phClr">
-                <a:tint val="40000"/>
-                <a:satMod val="350000"/>
+                <a:tint val="93000"/>
+                <a:satMod val="150000"/>
+                <a:shade val="98000"/>
+                <a:lumMod val="102000"/>
               </a:schemeClr>
             </a:gs>
-            <a:gs pos="40000">
+            <a:gs pos="50000">
               <a:schemeClr val="phClr">
-                <a:tint val="45000"/>
-                <a:shade val="99000"/>
-                <a:satMod val="350000"/>
+                <a:tint val="98000"/>
+                <a:satMod val="130000"/>
+                <a:shade val="90000"/>
+                <a:lumMod val="103000"/>
               </a:schemeClr>
             </a:gs>
             <a:gs pos="100000">
               <a:schemeClr val="phClr">
-                <a:shade val="20000"/>
-                <a:satMod val="255000"/>
+                <a:shade val="63000"/>
+                <a:satMod val="120000"/>
               </a:schemeClr>
             </a:gs>
           </a:gsLst>
-          <a:path path="circle">
-            <a:fillToRect l="50000" t="-80000" r="50000" b="180000"/>
-          </a:path>
-        </a:gradFill>
-        <a:gradFill rotWithShape="1">
-          <a:gsLst>
-            <a:gs pos="0">
-              <a:schemeClr val="phClr">
-                <a:tint val="80000"/>
-                <a:satMod val="300000"/>
-              </a:schemeClr>
-            </a:gs>
-            <a:gs pos="100000">
-              <a:schemeClr val="phClr">
-                <a:shade val="30000"/>
-                <a:satMod val="200000"/>
-              </a:schemeClr>
-            </a:gs>
-          </a:gsLst>
-          <a:path path="circle">
-            <a:fillToRect l="50000" t="50000" r="50000" b="50000"/>
-          </a:path>
+          <a:lin ang="5400000" scaled="0"/>
         </a:gradFill>
       </a:bgFillStyleLst>
     </a:fmtScheme>
   </a:themeElements>
   <a:objectDefaults>
-    <a:spDef>
-      <a:spPr/>
-      <a:bodyPr/>
-      <a:lstStyle/>
-      <a:style>
-        <a:lnRef idx="1">
-          <a:schemeClr val="accent1"/>
-        </a:lnRef>
-        <a:fillRef idx="3">
-          <a:schemeClr val="accent1"/>
-        </a:fillRef>
-        <a:effectRef idx="2">
-          <a:schemeClr val="accent1"/>
-        </a:effectRef>
-        <a:fontRef idx="minor">
-          <a:schemeClr val="lt1"/>
-        </a:fontRef>
-      </a:style>
-    </a:spDef>
     <a:lnDef>
       <a:spPr/>
       <a:bodyPr/>
@@ -15324,5 +15391,10 @@
     </a:lnDef>
   </a:objectDefaults>
   <a:extraClrSchemeLst/>
+  <a:extLst>
+    <a:ext uri="{05A4C25C-085E-4340-85A3-A5531E510DB2}">
+      <thm15:themeFamily xmlns:thm15="http://schemas.microsoft.com/office/thememl/2012/main" name="Office Theme" id="{2E142A2C-CD16-42D6-873A-C26D2A0506FA}" vid="{1BDDFF52-6CD6-40A5-AB3C-68EB2F1E4D0A}"/>
+    </a:ext>
+  </a:extLst>
 </a:theme>
 </file>
</xml_diff>